<commit_message>
docs: localize demo and add guided validation
</commit_message>
<xml_diff>
--- a/docs/demo/ExecLocus_intro_ja.pptx
+++ b/docs/demo/ExecLocus_intro_ja.pptx
@@ -2,19 +2,19 @@
 <file path=ppt/presentation.xml><?xml version="1.0" encoding="utf-8"?>
 <p:presentation xmlns:p="http://schemas.openxmlformats.org/presentationml/2006/main">
   <p:sldMasterIdLst>
-    <p:sldMasterId xmlns:r="http://schemas.openxmlformats.org/officeDocument/2006/relationships" id="2147483648" r:id="R39429e2797fb4e09"/>
+    <p:sldMasterId xmlns:r="http://schemas.openxmlformats.org/officeDocument/2006/relationships" id="2147483648" r:id="Rbac3b374641a49ed"/>
   </p:sldMasterIdLst>
   <p:notesMasterIdLst>
-    <p:notesMasterId xmlns:r="http://schemas.openxmlformats.org/officeDocument/2006/relationships" r:id="R53d3174d140e4d0b"/>
+    <p:notesMasterId xmlns:r="http://schemas.openxmlformats.org/officeDocument/2006/relationships" r:id="R65fc9b072f744d8b"/>
   </p:notesMasterIdLst>
   <p:sldIdLst>
-    <p:sldId xmlns:r="http://schemas.openxmlformats.org/officeDocument/2006/relationships" id="256" r:id="Ra6f7e09a563b415e"/>
-    <p:sldId xmlns:r="http://schemas.openxmlformats.org/officeDocument/2006/relationships" id="257" r:id="R1bd3aa4e64694712"/>
-    <p:sldId xmlns:r="http://schemas.openxmlformats.org/officeDocument/2006/relationships" id="258" r:id="R569e71d98e444c5c"/>
-    <p:sldId xmlns:r="http://schemas.openxmlformats.org/officeDocument/2006/relationships" id="259" r:id="R8200a6f0f9ee4b42"/>
-    <p:sldId xmlns:r="http://schemas.openxmlformats.org/officeDocument/2006/relationships" id="260" r:id="Rd4812c83ba364630"/>
-    <p:sldId xmlns:r="http://schemas.openxmlformats.org/officeDocument/2006/relationships" id="261" r:id="Rd3ae2c8419b94625"/>
-    <p:sldId xmlns:r="http://schemas.openxmlformats.org/officeDocument/2006/relationships" id="262" r:id="Rad4edebde80d4921"/>
+    <p:sldId xmlns:r="http://schemas.openxmlformats.org/officeDocument/2006/relationships" id="256" r:id="R10582b3634d64f84"/>
+    <p:sldId xmlns:r="http://schemas.openxmlformats.org/officeDocument/2006/relationships" id="257" r:id="Rf80099a4671e4a5f"/>
+    <p:sldId xmlns:r="http://schemas.openxmlformats.org/officeDocument/2006/relationships" id="258" r:id="Rf1454e5b9ff441c3"/>
+    <p:sldId xmlns:r="http://schemas.openxmlformats.org/officeDocument/2006/relationships" id="259" r:id="R734d7be321644adf"/>
+    <p:sldId xmlns:r="http://schemas.openxmlformats.org/officeDocument/2006/relationships" id="260" r:id="R8121148f2a2245e5"/>
+    <p:sldId xmlns:r="http://schemas.openxmlformats.org/officeDocument/2006/relationships" id="261" r:id="Rabf1559796954bce"/>
+    <p:sldId xmlns:r="http://schemas.openxmlformats.org/officeDocument/2006/relationships" id="262" r:id="R468ebe803cd44381"/>
   </p:sldIdLst>
   <p:sldSz cx="12192000" cy="6858000"/>
   <p:notesSz cx="6858000" cy="9144000"/>
@@ -1006,7 +1006,7 @@
   </p:cSld>
   <p:clrMap bg1="lt1" tx1="dk1" bg2="lt2" tx2="dk2" accent1="accent1" accent2="accent2" accent3="accent3" accent4="accent4" accent5="accent5" accent6="accent6" hlink="hlink" folHlink="folHlink"/>
   <p:sldLayoutIdLst>
-    <p:sldLayoutId xmlns:r="http://schemas.openxmlformats.org/officeDocument/2006/relationships" id="2147483649" r:id="R25e92f25695344cd"/>
+    <p:sldLayoutId xmlns:r="http://schemas.openxmlformats.org/officeDocument/2006/relationships" id="2147483649" r:id="Rc0cbd01a22194dd6"/>
   </p:sldLayoutIdLst>
   <p:txStyles>
     <p:titleStyle>
@@ -1557,7 +1557,7 @@
           <p:cNvPr id="9" name="">
             <a:extLst xmlns:a="http://schemas.openxmlformats.org/drawingml/2006/main">
               <a:ext uri="{FF2B5EF4-FFF2-40B4-BE49-F238E27FC236}">
-                <a16:creationId xmlns:a16="http://schemas.microsoft.com/office/drawing/2014/main" id="{68816A7A-A04E-4F69-8335-82A349C72C55}"/>
+                <a16:creationId xmlns:a16="http://schemas.microsoft.com/office/drawing/2014/main" id="{6A569C68-589B-415A-B62F-CE27015BB0FF}"/>
               </a:ext>
             </a:extLst>
           </p:cNvPr>
@@ -1596,7 +1596,7 @@
           <p:nvPr/>
         </p:nvPicPr>
         <p:blipFill>
-          <a:blip xmlns:r="http://schemas.openxmlformats.org/officeDocument/2006/relationships" xmlns:a="http://schemas.openxmlformats.org/drawingml/2006/main" r:embed="Raf692f368d34465d"/>
+          <a:blip xmlns:r="http://schemas.openxmlformats.org/officeDocument/2006/relationships" xmlns:a="http://schemas.openxmlformats.org/drawingml/2006/main" r:embed="R32646ef5fc2f4dba"/>
           <a:stretch xmlns:a="http://schemas.openxmlformats.org/drawingml/2006/main"/>
         </p:blipFill>
         <p:spPr>
@@ -1616,7 +1616,7 @@
           <p:cNvPr id="3" name="">
             <a:extLst xmlns:a="http://schemas.openxmlformats.org/drawingml/2006/main">
               <a:ext uri="{FF2B5EF4-FFF2-40B4-BE49-F238E27FC236}">
-                <a16:creationId xmlns:a16="http://schemas.microsoft.com/office/drawing/2014/main" id="{9EBE6835-FD2A-4539-ABAE-3DD4AF1B22B0}"/>
+                <a16:creationId xmlns:a16="http://schemas.microsoft.com/office/drawing/2014/main" id="{79F5C337-603D-4A8C-AB5C-04D9102BFFCA}"/>
               </a:ext>
             </a:extLst>
           </p:cNvPr>
@@ -1647,7 +1647,7 @@
           <p:cNvPr id="4" name="">
             <a:extLst xmlns:a="http://schemas.openxmlformats.org/drawingml/2006/main">
               <a:ext uri="{FF2B5EF4-FFF2-40B4-BE49-F238E27FC236}">
-                <a16:creationId xmlns:a16="http://schemas.microsoft.com/office/drawing/2014/main" id="{A19E2E63-8548-4152-843F-6502C42D45C2}"/>
+                <a16:creationId xmlns:a16="http://schemas.microsoft.com/office/drawing/2014/main" id="{F60EF9D9-9009-407E-814B-0B29BE96CB37}"/>
               </a:ext>
             </a:extLst>
           </p:cNvPr>
@@ -1697,7 +1697,7 @@
           <p:cNvPr id="5" name="">
             <a:extLst xmlns:a="http://schemas.openxmlformats.org/drawingml/2006/main">
               <a:ext uri="{FF2B5EF4-FFF2-40B4-BE49-F238E27FC236}">
-                <a16:creationId xmlns:a16="http://schemas.microsoft.com/office/drawing/2014/main" id="{26BA49DD-DB7E-4B99-B2ED-0C9501C0C1E1}"/>
+                <a16:creationId xmlns:a16="http://schemas.microsoft.com/office/drawing/2014/main" id="{89557E7D-A40E-4F14-9E9B-392AD4F3513C}"/>
               </a:ext>
             </a:extLst>
           </p:cNvPr>
@@ -1764,7 +1764,7 @@
           <p:cNvPr id="6" name="">
             <a:extLst xmlns:a="http://schemas.openxmlformats.org/drawingml/2006/main">
               <a:ext uri="{FF2B5EF4-FFF2-40B4-BE49-F238E27FC236}">
-                <a16:creationId xmlns:a16="http://schemas.microsoft.com/office/drawing/2014/main" id="{62A21A8F-8432-4FA6-AFFF-714F1F3B657F}"/>
+                <a16:creationId xmlns:a16="http://schemas.microsoft.com/office/drawing/2014/main" id="{D5BE8A7A-F7E8-4A16-B080-D5589BDAEE10}"/>
               </a:ext>
             </a:extLst>
           </p:cNvPr>
@@ -1804,7 +1804,7 @@
                   <a:srgbClr val="8AA4AC"/>
                 </a:solidFill>
               </a:rPr>
-              <a:t>AI coding agentの実行context、候補、</a:t>
+              <a:t>AIコーディングエージェントの実行環境、候補、</a:t>
             </a:r>
           </a:p>
           <a:p xmlns:a="http://schemas.openxmlformats.org/drawingml/2006/main">
@@ -1821,7 +1821,7 @@
                   <a:srgbClr val="8AA4AC"/>
                 </a:solidFill>
               </a:rPr>
-              <a:t>filesystemの意図を1回の診断へ。</a:t>
+              <a:t>ファイル配置の意図を1回の診断へ。</a:t>
             </a:r>
           </a:p>
         </p:txBody>
@@ -1831,7 +1831,7 @@
           <p:cNvPr id="7" name="">
             <a:extLst xmlns:a="http://schemas.openxmlformats.org/drawingml/2006/main">
               <a:ext uri="{FF2B5EF4-FFF2-40B4-BE49-F238E27FC236}">
-                <a16:creationId xmlns:a16="http://schemas.microsoft.com/office/drawing/2014/main" id="{7117771D-610C-493B-8064-6D7227F74865}"/>
+                <a16:creationId xmlns:a16="http://schemas.microsoft.com/office/drawing/2014/main" id="{DF26695E-118E-4092-987A-2AE96C50CC0F}"/>
               </a:ext>
             </a:extLst>
           </p:cNvPr>
@@ -1871,7 +1871,7 @@
                   <a:srgbClr val="69E3CC"/>
                 </a:solidFill>
               </a:rPr>
-              <a:t>LOCAL ONLY  ·  READ ONLY  ·  NO TELEMETRY</a:t>
+              <a:t>ローカルのみ  ·  読み取り専用  ·  送信なし</a:t>
             </a:r>
           </a:p>
         </p:txBody>
@@ -1881,7 +1881,7 @@
           <p:cNvPr id="8" name="">
             <a:extLst xmlns:a="http://schemas.openxmlformats.org/drawingml/2006/main">
               <a:ext uri="{FF2B5EF4-FFF2-40B4-BE49-F238E27FC236}">
-                <a16:creationId xmlns:a16="http://schemas.microsoft.com/office/drawing/2014/main" id="{5682AD73-A18B-4B26-9C68-D22C1AEDF8FA}"/>
+                <a16:creationId xmlns:a16="http://schemas.microsoft.com/office/drawing/2014/main" id="{EA13CE1A-CEA7-4573-B474-C3DA3F33A886}"/>
               </a:ext>
             </a:extLst>
           </p:cNvPr>
@@ -1921,7 +1921,7 @@
                   <a:srgbClr val="8AA4AC"/>
                 </a:solidFill>
               </a:rPr>
-              <a:t>v0.1 source prototype</a:t>
+              <a:t>v0.1 ソース版</a:t>
             </a:r>
           </a:p>
         </p:txBody>
@@ -1929,7 +1929,7 @@
     </p:spTree>
     <p:extLst>
       <p:ext uri="{BB962C8B-B14F-4D97-AF65-F5344CB8AC3E}">
-        <p14:creationId xmlns:p14="http://schemas.microsoft.com/office/powerpoint/2010/main" val="873160396"/>
+        <p14:creationId xmlns:p14="http://schemas.microsoft.com/office/powerpoint/2010/main" val="129938683"/>
       </p:ext>
     </p:extLst>
   </p:cSld>
@@ -1960,7 +1960,7 @@
           <p:cNvPr id="9" name="">
             <a:extLst xmlns:a="http://schemas.openxmlformats.org/drawingml/2006/main">
               <a:ext uri="{FF2B5EF4-FFF2-40B4-BE49-F238E27FC236}">
-                <a16:creationId xmlns:a16="http://schemas.microsoft.com/office/drawing/2014/main" id="{B0A78D78-3A58-4431-B8D2-654C2F89FDAE}"/>
+                <a16:creationId xmlns:a16="http://schemas.microsoft.com/office/drawing/2014/main" id="{C2F8E3BD-FD3F-4F41-A8A3-167878352213}"/>
               </a:ext>
             </a:extLst>
           </p:cNvPr>
@@ -2000,7 +2000,7 @@
                   <a:srgbClr val="69E3CC"/>
                 </a:solidFill>
               </a:rPr>
-              <a:t>01 · WHY</a:t>
+              <a:t>01 · 背景</a:t>
             </a:r>
           </a:p>
         </p:txBody>
@@ -2010,7 +2010,7 @@
           <p:cNvPr id="2" name="">
             <a:extLst xmlns:a="http://schemas.openxmlformats.org/drawingml/2006/main">
               <a:ext uri="{FF2B5EF4-FFF2-40B4-BE49-F238E27FC236}">
-                <a16:creationId xmlns:a16="http://schemas.microsoft.com/office/drawing/2014/main" id="{D60B5FE1-2B70-4EBB-929C-5573B6BBAE89}"/>
+                <a16:creationId xmlns:a16="http://schemas.microsoft.com/office/drawing/2014/main" id="{CCFB69B4-F2CC-4BCB-8B6C-7C908D6A613D}"/>
               </a:ext>
             </a:extLst>
           </p:cNvPr>
@@ -2050,7 +2050,7 @@
                   <a:srgbClr val="8AA4AC"/>
                 </a:solidFill>
               </a:rPr>
-              <a:t>2026.07 · SOURCE PROTOTYPE</a:t>
+              <a:t>2026.07 · ソース版</a:t>
             </a:r>
           </a:p>
         </p:txBody>
@@ -2060,7 +2060,7 @@
           <p:cNvPr id="3" name="">
             <a:extLst xmlns:a="http://schemas.openxmlformats.org/drawingml/2006/main">
               <a:ext uri="{FF2B5EF4-FFF2-40B4-BE49-F238E27FC236}">
-                <a16:creationId xmlns:a16="http://schemas.microsoft.com/office/drawing/2014/main" id="{C9BF916E-7E3B-4524-88E9-1799AEA51EC6}"/>
+                <a16:creationId xmlns:a16="http://schemas.microsoft.com/office/drawing/2014/main" id="{2B53260A-D3FC-4A51-984E-75D80A645833}"/>
               </a:ext>
             </a:extLst>
           </p:cNvPr>
@@ -2100,7 +2100,7 @@
                   <a:srgbClr val="E7FBF6"/>
                 </a:solidFill>
               </a:rPr>
-              <a:t>同じprojectでも、選ばれるNodeは同じとは限らない。</a:t>
+              <a:t>同じプロジェクトでも、選ばれるNodeは同じとは限らない。</a:t>
             </a:r>
           </a:p>
         </p:txBody>
@@ -2110,7 +2110,7 @@
           <p:cNvPr id="4" name="">
             <a:extLst xmlns:a="http://schemas.openxmlformats.org/drawingml/2006/main">
               <a:ext uri="{FF2B5EF4-FFF2-40B4-BE49-F238E27FC236}">
-                <a16:creationId xmlns:a16="http://schemas.microsoft.com/office/drawing/2014/main" id="{B93F9C2C-53F5-453B-97DB-1A764D0982BA}"/>
+                <a16:creationId xmlns:a16="http://schemas.microsoft.com/office/drawing/2014/main" id="{8483EB6A-F3A6-46D5-BE57-FE6053928A86}"/>
               </a:ext>
             </a:extLst>
           </p:cNvPr>
@@ -2150,7 +2150,7 @@
                   <a:srgbClr val="8AA4AC"/>
                 </a:solidFill>
               </a:rPr>
-              <a:t>WindowsとWSLは別の実行context。見えているsource treeが同じでも、shell contractと実行形式は分かれます。</a:t>
+              <a:t>WindowsとWSLは別の実行環境。同じソース一式でも、シェルの規則と実行形式は分かれます。</a:t>
             </a:r>
           </a:p>
         </p:txBody>
@@ -2164,7 +2164,7 @@
           <p:nvPr/>
         </p:nvPicPr>
         <p:blipFill>
-          <a:blip xmlns:r="http://schemas.openxmlformats.org/officeDocument/2006/relationships" xmlns:a="http://schemas.openxmlformats.org/drawingml/2006/main" r:embed="R7b32874639aa4b44"/>
+          <a:blip xmlns:r="http://schemas.openxmlformats.org/officeDocument/2006/relationships" xmlns:a="http://schemas.openxmlformats.org/drawingml/2006/main" r:embed="R92d2f6e640824ea0"/>
           <a:srcRect xmlns:a="http://schemas.openxmlformats.org/drawingml/2006/main" l="0" t="17467" r="0" b="17467"/>
           <a:stretch xmlns:a="http://schemas.openxmlformats.org/drawingml/2006/main">
             <a:fillRect l="0" t="0" r="0" b="0"/>
@@ -2187,7 +2187,7 @@
           <p:cNvPr id="6" name="">
             <a:extLst xmlns:a="http://schemas.openxmlformats.org/drawingml/2006/main">
               <a:ext uri="{FF2B5EF4-FFF2-40B4-BE49-F238E27FC236}">
-                <a16:creationId xmlns:a16="http://schemas.microsoft.com/office/drawing/2014/main" id="{21C58546-5BC9-44A4-AF13-2E84E8C39A83}"/>
+                <a16:creationId xmlns:a16="http://schemas.microsoft.com/office/drawing/2014/main" id="{8211BB3A-F091-4DD6-84C7-B423020E3913}"/>
               </a:ext>
             </a:extLst>
           </p:cNvPr>
@@ -2218,7 +2218,7 @@
           <p:cNvPr id="7" name="">
             <a:extLst xmlns:a="http://schemas.openxmlformats.org/drawingml/2006/main">
               <a:ext uri="{FF2B5EF4-FFF2-40B4-BE49-F238E27FC236}">
-                <a16:creationId xmlns:a16="http://schemas.microsoft.com/office/drawing/2014/main" id="{C1F6B2C1-3DFB-46D4-882B-62B55AE0773D}"/>
+                <a16:creationId xmlns:a16="http://schemas.microsoft.com/office/drawing/2014/main" id="{AF0645B2-5864-44DD-A76C-1B1C5B6B3570}"/>
               </a:ext>
             </a:extLst>
           </p:cNvPr>
@@ -2268,7 +2268,7 @@
           <p:cNvPr id="8" name="">
             <a:extLst xmlns:a="http://schemas.openxmlformats.org/drawingml/2006/main">
               <a:ext uri="{FF2B5EF4-FFF2-40B4-BE49-F238E27FC236}">
-                <a16:creationId xmlns:a16="http://schemas.microsoft.com/office/drawing/2014/main" id="{394B07AF-CEE3-4A41-81F8-248A249E65DD}"/>
+                <a16:creationId xmlns:a16="http://schemas.microsoft.com/office/drawing/2014/main" id="{C2AD2AF8-F74F-4674-9D86-22B9A21A9676}"/>
               </a:ext>
             </a:extLst>
           </p:cNvPr>
@@ -2316,7 +2316,7 @@
     </p:spTree>
     <p:extLst>
       <p:ext uri="{BB962C8B-B14F-4D97-AF65-F5344CB8AC3E}">
-        <p14:creationId xmlns:p14="http://schemas.microsoft.com/office/powerpoint/2010/main" val="2019881673"/>
+        <p14:creationId xmlns:p14="http://schemas.microsoft.com/office/powerpoint/2010/main" val="1726707143"/>
       </p:ext>
     </p:extLst>
   </p:cSld>
@@ -2347,7 +2347,7 @@
           <p:cNvPr id="21" name="">
             <a:extLst xmlns:a="http://schemas.openxmlformats.org/drawingml/2006/main">
               <a:ext uri="{FF2B5EF4-FFF2-40B4-BE49-F238E27FC236}">
-                <a16:creationId xmlns:a16="http://schemas.microsoft.com/office/drawing/2014/main" id="{852217D0-CFCB-4339-98FE-B04D13D59CC2}"/>
+                <a16:creationId xmlns:a16="http://schemas.microsoft.com/office/drawing/2014/main" id="{6DEC9755-740F-4ADA-814E-9511A1658B11}"/>
               </a:ext>
             </a:extLst>
           </p:cNvPr>
@@ -2387,7 +2387,7 @@
                   <a:srgbClr val="69E3CC"/>
                 </a:solidFill>
               </a:rPr>
-              <a:t>02 · WHAT IT ANSWERS</a:t>
+              <a:t>02 · 分かること</a:t>
             </a:r>
           </a:p>
         </p:txBody>
@@ -2397,7 +2397,7 @@
           <p:cNvPr id="2" name="">
             <a:extLst xmlns:a="http://schemas.openxmlformats.org/drawingml/2006/main">
               <a:ext uri="{FF2B5EF4-FFF2-40B4-BE49-F238E27FC236}">
-                <a16:creationId xmlns:a16="http://schemas.microsoft.com/office/drawing/2014/main" id="{89483B1D-CDA9-4682-9D03-121C41279FDB}"/>
+                <a16:creationId xmlns:a16="http://schemas.microsoft.com/office/drawing/2014/main" id="{D8B887D6-2CD6-4D26-B96B-A6454EC0D468}"/>
               </a:ext>
             </a:extLst>
           </p:cNvPr>
@@ -2437,7 +2437,7 @@
                   <a:srgbClr val="8AA4AC"/>
                 </a:solidFill>
               </a:rPr>
-              <a:t>2026.07 · SOURCE PROTOTYPE</a:t>
+              <a:t>2026.07 · ソース版</a:t>
             </a:r>
           </a:p>
         </p:txBody>
@@ -2447,7 +2447,7 @@
           <p:cNvPr id="3" name="">
             <a:extLst xmlns:a="http://schemas.openxmlformats.org/drawingml/2006/main">
               <a:ext uri="{FF2B5EF4-FFF2-40B4-BE49-F238E27FC236}">
-                <a16:creationId xmlns:a16="http://schemas.microsoft.com/office/drawing/2014/main" id="{369E12A0-31AD-4DB0-90B1-477AF63CDBAF}"/>
+                <a16:creationId xmlns:a16="http://schemas.microsoft.com/office/drawing/2014/main" id="{AF3B3FE5-868F-41F1-AE37-D3A13D4FCA8C}"/>
               </a:ext>
             </a:extLst>
           </p:cNvPr>
@@ -2487,7 +2487,7 @@
                   <a:srgbClr val="E7FBF6"/>
                 </a:solidFill>
               </a:rPr>
-              <a:t>手作業で分かれていた3つの確認を、同じevidence modelへ。</a:t>
+              <a:t>手作業で分かれていた3つの確認を、同じ根拠モデルへ。</a:t>
             </a:r>
           </a:p>
         </p:txBody>
@@ -2497,7 +2497,7 @@
           <p:cNvPr id="4" name="">
             <a:extLst xmlns:a="http://schemas.openxmlformats.org/drawingml/2006/main">
               <a:ext uri="{FF2B5EF4-FFF2-40B4-BE49-F238E27FC236}">
-                <a16:creationId xmlns:a16="http://schemas.microsoft.com/office/drawing/2014/main" id="{505D3BD3-2693-4530-961A-11C458FE35DE}"/>
+                <a16:creationId xmlns:a16="http://schemas.microsoft.com/office/drawing/2014/main" id="{611F7BAE-47BD-4225-9B06-9BE44CC0B869}"/>
               </a:ext>
             </a:extLst>
           </p:cNvPr>
@@ -2528,7 +2528,7 @@
           <p:cNvPr id="5" name="">
             <a:extLst xmlns:a="http://schemas.openxmlformats.org/drawingml/2006/main">
               <a:ext uri="{FF2B5EF4-FFF2-40B4-BE49-F238E27FC236}">
-                <a16:creationId xmlns:a16="http://schemas.microsoft.com/office/drawing/2014/main" id="{4ED20D8D-995F-4903-AEBF-EA2525243CC3}"/>
+                <a16:creationId xmlns:a16="http://schemas.microsoft.com/office/drawing/2014/main" id="{AC573A77-8B02-4681-9EB6-8F961B119C4B}"/>
               </a:ext>
             </a:extLst>
           </p:cNvPr>
@@ -2563,7 +2563,7 @@
           <p:cNvPr id="6" name="">
             <a:extLst xmlns:a="http://schemas.openxmlformats.org/drawingml/2006/main">
               <a:ext uri="{FF2B5EF4-FFF2-40B4-BE49-F238E27FC236}">
-                <a16:creationId xmlns:a16="http://schemas.microsoft.com/office/drawing/2014/main" id="{C26A9BF4-A603-4359-A487-3E391FEA276F}"/>
+                <a16:creationId xmlns:a16="http://schemas.microsoft.com/office/drawing/2014/main" id="{2B1393EB-59E1-4603-A40B-FDC4C827989A}"/>
               </a:ext>
             </a:extLst>
           </p:cNvPr>
@@ -2613,7 +2613,7 @@
           <p:cNvPr id="7" name="">
             <a:extLst xmlns:a="http://schemas.openxmlformats.org/drawingml/2006/main">
               <a:ext uri="{FF2B5EF4-FFF2-40B4-BE49-F238E27FC236}">
-                <a16:creationId xmlns:a16="http://schemas.microsoft.com/office/drawing/2014/main" id="{0133E5A7-7FD3-4BBD-82E8-F0AEAD776B4E}"/>
+                <a16:creationId xmlns:a16="http://schemas.microsoft.com/office/drawing/2014/main" id="{4FAA1849-3C0C-4F0B-B146-5D80E5A1DB33}"/>
               </a:ext>
             </a:extLst>
           </p:cNvPr>
@@ -2663,7 +2663,7 @@
           <p:cNvPr id="8" name="">
             <a:extLst xmlns:a="http://schemas.openxmlformats.org/drawingml/2006/main">
               <a:ext uri="{FF2B5EF4-FFF2-40B4-BE49-F238E27FC236}">
-                <a16:creationId xmlns:a16="http://schemas.microsoft.com/office/drawing/2014/main" id="{1FD6D3AD-EFCB-4B97-9DCA-1B0BA6D14928}"/>
+                <a16:creationId xmlns:a16="http://schemas.microsoft.com/office/drawing/2014/main" id="{106DCAB4-8597-468E-871F-364AB3B45793}"/>
               </a:ext>
             </a:extLst>
           </p:cNvPr>
@@ -2703,7 +2703,7 @@
                   <a:srgbClr val="8AA4AC"/>
                 </a:solidFill>
               </a:rPr>
-              <a:t>Windows / WSL、distribution、user、shell、agent runtime evidenceを分離。</a:t>
+              <a:t>Windows／WSL、ディストリビューション、利用者、シェル、エージェントの根拠を分離。</a:t>
             </a:r>
           </a:p>
         </p:txBody>
@@ -2713,7 +2713,7 @@
           <p:cNvPr id="9" name="">
             <a:extLst xmlns:a="http://schemas.openxmlformats.org/drawingml/2006/main">
               <a:ext uri="{FF2B5EF4-FFF2-40B4-BE49-F238E27FC236}">
-                <a16:creationId xmlns:a16="http://schemas.microsoft.com/office/drawing/2014/main" id="{A8C748E5-D83A-42B9-8A78-7DE28911E6FE}"/>
+                <a16:creationId xmlns:a16="http://schemas.microsoft.com/office/drawing/2014/main" id="{CA8F4EF6-C2BE-4C74-AF1C-E1B774A2761E}"/>
               </a:ext>
             </a:extLst>
           </p:cNvPr>
@@ -2748,7 +2748,7 @@
           <p:cNvPr id="10" name="">
             <a:extLst xmlns:a="http://schemas.openxmlformats.org/drawingml/2006/main">
               <a:ext uri="{FF2B5EF4-FFF2-40B4-BE49-F238E27FC236}">
-                <a16:creationId xmlns:a16="http://schemas.microsoft.com/office/drawing/2014/main" id="{25EF231E-E148-41BF-88FD-06076C0F7D1B}"/>
+                <a16:creationId xmlns:a16="http://schemas.microsoft.com/office/drawing/2014/main" id="{BBD04AC7-817B-4D00-BEA0-CD7ACFBCBDEF}"/>
               </a:ext>
             </a:extLst>
           </p:cNvPr>
@@ -2798,7 +2798,7 @@
           <p:cNvPr id="11" name="">
             <a:extLst xmlns:a="http://schemas.openxmlformats.org/drawingml/2006/main">
               <a:ext uri="{FF2B5EF4-FFF2-40B4-BE49-F238E27FC236}">
-                <a16:creationId xmlns:a16="http://schemas.microsoft.com/office/drawing/2014/main" id="{1EB55A98-8331-4201-B3BF-5C6500357D39}"/>
+                <a16:creationId xmlns:a16="http://schemas.microsoft.com/office/drawing/2014/main" id="{353AA243-9B0D-4187-86E8-794E9E4EA45B}"/>
               </a:ext>
             </a:extLst>
           </p:cNvPr>
@@ -2848,7 +2848,7 @@
           <p:cNvPr id="12" name="">
             <a:extLst xmlns:a="http://schemas.openxmlformats.org/drawingml/2006/main">
               <a:ext uri="{FF2B5EF4-FFF2-40B4-BE49-F238E27FC236}">
-                <a16:creationId xmlns:a16="http://schemas.microsoft.com/office/drawing/2014/main" id="{05034AC6-72EE-4B4A-AA20-A4EF064BA92D}"/>
+                <a16:creationId xmlns:a16="http://schemas.microsoft.com/office/drawing/2014/main" id="{283AFB6F-F9D9-4BD3-8EF9-3E1E1041DFA8}"/>
               </a:ext>
             </a:extLst>
           </p:cNvPr>
@@ -2888,7 +2888,7 @@
                   <a:srgbClr val="8AA4AC"/>
                 </a:solidFill>
               </a:rPr>
-              <a:t>selected candidate、losing candidate、実行形式、shell contractの根拠を表示。</a:t>
+              <a:t>選択候補、不採用候補、実行形式、シェル規則の根拠を表示。</a:t>
             </a:r>
           </a:p>
         </p:txBody>
@@ -2898,7 +2898,7 @@
           <p:cNvPr id="13" name="">
             <a:extLst xmlns:a="http://schemas.openxmlformats.org/drawingml/2006/main">
               <a:ext uri="{FF2B5EF4-FFF2-40B4-BE49-F238E27FC236}">
-                <a16:creationId xmlns:a16="http://schemas.microsoft.com/office/drawing/2014/main" id="{BA5B236D-75F0-4501-B189-FE226231BF23}"/>
+                <a16:creationId xmlns:a16="http://schemas.microsoft.com/office/drawing/2014/main" id="{76CF1587-BDC0-4417-957C-71D344766EBD}"/>
               </a:ext>
             </a:extLst>
           </p:cNvPr>
@@ -2933,7 +2933,7 @@
           <p:cNvPr id="14" name="">
             <a:extLst xmlns:a="http://schemas.openxmlformats.org/drawingml/2006/main">
               <a:ext uri="{FF2B5EF4-FFF2-40B4-BE49-F238E27FC236}">
-                <a16:creationId xmlns:a16="http://schemas.microsoft.com/office/drawing/2014/main" id="{9FC5C6CD-CD3D-457B-8BC5-A67D3523DFC6}"/>
+                <a16:creationId xmlns:a16="http://schemas.microsoft.com/office/drawing/2014/main" id="{CEF04883-06FC-4085-B56D-C49DA00B4817}"/>
               </a:ext>
             </a:extLst>
           </p:cNvPr>
@@ -2983,7 +2983,7 @@
           <p:cNvPr id="15" name="">
             <a:extLst xmlns:a="http://schemas.openxmlformats.org/drawingml/2006/main">
               <a:ext uri="{FF2B5EF4-FFF2-40B4-BE49-F238E27FC236}">
-                <a16:creationId xmlns:a16="http://schemas.microsoft.com/office/drawing/2014/main" id="{C16AC213-7B02-437E-BBE8-ED831DEFEB98}"/>
+                <a16:creationId xmlns:a16="http://schemas.microsoft.com/office/drawing/2014/main" id="{5D2CD964-1066-46A4-84A0-43F2B85C9DCE}"/>
               </a:ext>
             </a:extLst>
           </p:cNvPr>
@@ -3033,7 +3033,7 @@
           <p:cNvPr id="16" name="">
             <a:extLst xmlns:a="http://schemas.openxmlformats.org/drawingml/2006/main">
               <a:ext uri="{FF2B5EF4-FFF2-40B4-BE49-F238E27FC236}">
-                <a16:creationId xmlns:a16="http://schemas.microsoft.com/office/drawing/2014/main" id="{996D4A4F-6C65-4469-A757-2D57CA7385AB}"/>
+                <a16:creationId xmlns:a16="http://schemas.microsoft.com/office/drawing/2014/main" id="{26339FA4-00A6-48BD-BFDE-EEF15E518745}"/>
               </a:ext>
             </a:extLst>
           </p:cNvPr>
@@ -3073,7 +3073,7 @@
                   <a:srgbClr val="8AA4AC"/>
                 </a:solidFill>
               </a:rPr>
-              <a:t>/mnt/cを一律否定せず、share-first / balanced / linux-firstで判断。</a:t>
+              <a:t>/mnt/cを一律否定せず、3つの利用目的で判断。</a:t>
             </a:r>
           </a:p>
         </p:txBody>
@@ -3083,7 +3083,7 @@
           <p:cNvPr id="17" name="">
             <a:extLst xmlns:a="http://schemas.openxmlformats.org/drawingml/2006/main">
               <a:ext uri="{FF2B5EF4-FFF2-40B4-BE49-F238E27FC236}">
-                <a16:creationId xmlns:a16="http://schemas.microsoft.com/office/drawing/2014/main" id="{DA96576F-E592-4730-B5C1-63AECBEE6210}"/>
+                <a16:creationId xmlns:a16="http://schemas.microsoft.com/office/drawing/2014/main" id="{740D6BBA-3730-4139-807E-E16A043402F0}"/>
               </a:ext>
             </a:extLst>
           </p:cNvPr>
@@ -3123,7 +3123,7 @@
                   <a:srgbClr val="55B8FF"/>
                 </a:solidFill>
               </a:rPr>
-              <a:t>観測できないものは、推測で埋めず unavailable / inferred として残します。</a:t>
+              <a:t>観測できないものは推測で埋めず、「取得不可」または「推定」として残します。</a:t>
             </a:r>
           </a:p>
         </p:txBody>
@@ -3133,7 +3133,7 @@
           <p:cNvPr id="18" name="">
             <a:extLst xmlns:a="http://schemas.openxmlformats.org/drawingml/2006/main">
               <a:ext uri="{FF2B5EF4-FFF2-40B4-BE49-F238E27FC236}">
-                <a16:creationId xmlns:a16="http://schemas.microsoft.com/office/drawing/2014/main" id="{3024543C-C91C-4F1D-B1C3-6B0EA11C3730}"/>
+                <a16:creationId xmlns:a16="http://schemas.microsoft.com/office/drawing/2014/main" id="{E3072A34-D914-4416-B4F3-F2B5A944D5B5}"/>
               </a:ext>
             </a:extLst>
           </p:cNvPr>
@@ -3164,7 +3164,7 @@
           <p:cNvPr id="19" name="">
             <a:extLst xmlns:a="http://schemas.openxmlformats.org/drawingml/2006/main">
               <a:ext uri="{FF2B5EF4-FFF2-40B4-BE49-F238E27FC236}">
-                <a16:creationId xmlns:a16="http://schemas.microsoft.com/office/drawing/2014/main" id="{B8616459-D3D6-4321-855A-3DB7C7F474EF}"/>
+                <a16:creationId xmlns:a16="http://schemas.microsoft.com/office/drawing/2014/main" id="{24E52EF0-FDAC-44EC-A95B-FB33507A10CF}"/>
               </a:ext>
             </a:extLst>
           </p:cNvPr>
@@ -3214,7 +3214,7 @@
           <p:cNvPr id="20" name="">
             <a:extLst xmlns:a="http://schemas.openxmlformats.org/drawingml/2006/main">
               <a:ext uri="{FF2B5EF4-FFF2-40B4-BE49-F238E27FC236}">
-                <a16:creationId xmlns:a16="http://schemas.microsoft.com/office/drawing/2014/main" id="{49D0B3EA-5FB6-4996-AE50-1F577662B098}"/>
+                <a16:creationId xmlns:a16="http://schemas.microsoft.com/office/drawing/2014/main" id="{F497402B-26CB-41EC-B656-9043BBE5CFAB}"/>
               </a:ext>
             </a:extLst>
           </p:cNvPr>
@@ -3262,7 +3262,7 @@
     </p:spTree>
     <p:extLst>
       <p:ext uri="{BB962C8B-B14F-4D97-AF65-F5344CB8AC3E}">
-        <p14:creationId xmlns:p14="http://schemas.microsoft.com/office/powerpoint/2010/main" val="225211521"/>
+        <p14:creationId xmlns:p14="http://schemas.microsoft.com/office/powerpoint/2010/main" val="467535348"/>
       </p:ext>
     </p:extLst>
   </p:cSld>
@@ -3293,7 +3293,7 @@
           <p:cNvPr id="17" name="">
             <a:extLst xmlns:a="http://schemas.openxmlformats.org/drawingml/2006/main">
               <a:ext uri="{FF2B5EF4-FFF2-40B4-BE49-F238E27FC236}">
-                <a16:creationId xmlns:a16="http://schemas.microsoft.com/office/drawing/2014/main" id="{4326CFBD-87EA-49EE-B266-A81937879892}"/>
+                <a16:creationId xmlns:a16="http://schemas.microsoft.com/office/drawing/2014/main" id="{2B6BF784-F4F3-44AF-8F35-2B956CCA0BF0}"/>
               </a:ext>
             </a:extLst>
           </p:cNvPr>
@@ -3333,7 +3333,7 @@
                   <a:srgbClr val="69E3CC"/>
                 </a:solidFill>
               </a:rPr>
-              <a:t>03 · HOW IT FEELS</a:t>
+              <a:t>03 · 操作の流れ</a:t>
             </a:r>
           </a:p>
         </p:txBody>
@@ -3343,7 +3343,7 @@
           <p:cNvPr id="2" name="">
             <a:extLst xmlns:a="http://schemas.openxmlformats.org/drawingml/2006/main">
               <a:ext uri="{FF2B5EF4-FFF2-40B4-BE49-F238E27FC236}">
-                <a16:creationId xmlns:a16="http://schemas.microsoft.com/office/drawing/2014/main" id="{6EA6F11B-6A9E-4B62-BD8C-D9B947DD17B2}"/>
+                <a16:creationId xmlns:a16="http://schemas.microsoft.com/office/drawing/2014/main" id="{E01C47B6-8143-440E-96BB-75ED853B09B6}"/>
               </a:ext>
             </a:extLst>
           </p:cNvPr>
@@ -3383,7 +3383,7 @@
                   <a:srgbClr val="8AA4AC"/>
                 </a:solidFill>
               </a:rPr>
-              <a:t>2026.07 · SOURCE PROTOTYPE</a:t>
+              <a:t>2026.07 · ソース版</a:t>
             </a:r>
           </a:p>
         </p:txBody>
@@ -3393,7 +3393,7 @@
           <p:cNvPr id="3" name="">
             <a:extLst xmlns:a="http://schemas.openxmlformats.org/drawingml/2006/main">
               <a:ext uri="{FF2B5EF4-FFF2-40B4-BE49-F238E27FC236}">
-                <a16:creationId xmlns:a16="http://schemas.microsoft.com/office/drawing/2014/main" id="{B4AE5E70-0142-4022-AE8F-B13A3C1E37FA}"/>
+                <a16:creationId xmlns:a16="http://schemas.microsoft.com/office/drawing/2014/main" id="{390874B1-C6E3-47BF-9C0D-D7617242ECDF}"/>
               </a:ext>
             </a:extLst>
           </p:cNvPr>
@@ -3433,7 +3433,7 @@
                   <a:srgbClr val="E7FBF6"/>
                 </a:solidFill>
               </a:rPr>
-              <a:t>1 commandから、比較・説明・安全な共有まで。</a:t>
+              <a:t>1つのコマンドから、比較・説明・安全な共有まで。</a:t>
             </a:r>
           </a:p>
         </p:txBody>
@@ -3447,16 +3447,13 @@
           <p:nvPr/>
         </p:nvPicPr>
         <p:blipFill>
-          <a:blip xmlns:r="http://schemas.openxmlformats.org/officeDocument/2006/relationships" xmlns:a="http://schemas.openxmlformats.org/drawingml/2006/main" r:embed="R3b70f9164d7a493c"/>
-          <a:srcRect xmlns:a="http://schemas.openxmlformats.org/drawingml/2006/main" l="24873" t="0" r="24873" b="0"/>
-          <a:stretch xmlns:a="http://schemas.openxmlformats.org/drawingml/2006/main">
-            <a:fillRect l="0" t="0" r="0" b="0"/>
-          </a:stretch>
+          <a:blip xmlns:r="http://schemas.openxmlformats.org/officeDocument/2006/relationships" xmlns:a="http://schemas.openxmlformats.org/drawingml/2006/main" r:embed="R52506ddb650f4cfe"/>
+          <a:stretch xmlns:a="http://schemas.openxmlformats.org/drawingml/2006/main"/>
         </p:blipFill>
         <p:spPr>
           <a:xfrm xmlns:a="http://schemas.openxmlformats.org/drawingml/2006/main">
-            <a:off x="514350" y="1819275"/>
-            <a:ext cx="2571750" cy="2952750"/>
+            <a:off x="514350" y="2553719"/>
+            <a:ext cx="2571750" cy="1483862"/>
           </a:xfrm>
           <a:prstGeom xmlns:a="http://schemas.openxmlformats.org/drawingml/2006/main" prst="roundRect">
             <a:avLst>
@@ -3470,7 +3467,7 @@
           <p:cNvPr id="5" name="">
             <a:extLst xmlns:a="http://schemas.openxmlformats.org/drawingml/2006/main">
               <a:ext uri="{FF2B5EF4-FFF2-40B4-BE49-F238E27FC236}">
-                <a16:creationId xmlns:a16="http://schemas.microsoft.com/office/drawing/2014/main" id="{595E2CED-94B9-4DFF-A9CC-E2D9B45B5104}"/>
+                <a16:creationId xmlns:a16="http://schemas.microsoft.com/office/drawing/2014/main" id="{73C6875E-BFFA-4BFC-8637-299443BA6E21}"/>
               </a:ext>
             </a:extLst>
           </p:cNvPr>
@@ -3510,7 +3507,7 @@
                   <a:srgbClr val="55B8FF"/>
                 </a:solidFill>
               </a:rPr>
-              <a:t>1  INSPECT</a:t>
+              <a:t>1  診断</a:t>
             </a:r>
           </a:p>
         </p:txBody>
@@ -3524,16 +3521,13 @@
           <p:nvPr/>
         </p:nvPicPr>
         <p:blipFill>
-          <a:blip xmlns:r="http://schemas.openxmlformats.org/officeDocument/2006/relationships" xmlns:a="http://schemas.openxmlformats.org/drawingml/2006/main" r:embed="Rb15ee6e3b657417f"/>
-          <a:srcRect xmlns:a="http://schemas.openxmlformats.org/drawingml/2006/main" l="24873" t="0" r="24873" b="0"/>
-          <a:stretch xmlns:a="http://schemas.openxmlformats.org/drawingml/2006/main">
-            <a:fillRect l="0" t="0" r="0" b="0"/>
-          </a:stretch>
+          <a:blip xmlns:r="http://schemas.openxmlformats.org/officeDocument/2006/relationships" xmlns:a="http://schemas.openxmlformats.org/drawingml/2006/main" r:embed="R9124a51af47446ec"/>
+          <a:stretch xmlns:a="http://schemas.openxmlformats.org/drawingml/2006/main"/>
         </p:blipFill>
         <p:spPr>
           <a:xfrm xmlns:a="http://schemas.openxmlformats.org/drawingml/2006/main">
-            <a:off x="3314700" y="1819275"/>
-            <a:ext cx="2571750" cy="2952750"/>
+            <a:off x="3314700" y="2553719"/>
+            <a:ext cx="2571750" cy="1483862"/>
           </a:xfrm>
           <a:prstGeom xmlns:a="http://schemas.openxmlformats.org/drawingml/2006/main" prst="roundRect">
             <a:avLst>
@@ -3547,7 +3541,7 @@
           <p:cNvPr id="7" name="">
             <a:extLst xmlns:a="http://schemas.openxmlformats.org/drawingml/2006/main">
               <a:ext uri="{FF2B5EF4-FFF2-40B4-BE49-F238E27FC236}">
-                <a16:creationId xmlns:a16="http://schemas.microsoft.com/office/drawing/2014/main" id="{BB2166BC-2C69-4D83-96A1-ED72462A31C0}"/>
+                <a16:creationId xmlns:a16="http://schemas.microsoft.com/office/drawing/2014/main" id="{C35687BC-1FEE-405C-A270-125F7C1B7E63}"/>
               </a:ext>
             </a:extLst>
           </p:cNvPr>
@@ -3587,7 +3581,7 @@
                   <a:srgbClr val="55B8FF"/>
                 </a:solidFill>
               </a:rPr>
-              <a:t>2  COMPARE</a:t>
+              <a:t>2  比較</a:t>
             </a:r>
           </a:p>
         </p:txBody>
@@ -3601,16 +3595,13 @@
           <p:nvPr/>
         </p:nvPicPr>
         <p:blipFill>
-          <a:blip xmlns:r="http://schemas.openxmlformats.org/officeDocument/2006/relationships" xmlns:a="http://schemas.openxmlformats.org/drawingml/2006/main" r:embed="Rf3eb528fbca14795"/>
-          <a:srcRect xmlns:a="http://schemas.openxmlformats.org/drawingml/2006/main" l="24873" t="0" r="24873" b="0"/>
-          <a:stretch xmlns:a="http://schemas.openxmlformats.org/drawingml/2006/main">
-            <a:fillRect l="0" t="0" r="0" b="0"/>
-          </a:stretch>
+          <a:blip xmlns:r="http://schemas.openxmlformats.org/officeDocument/2006/relationships" xmlns:a="http://schemas.openxmlformats.org/drawingml/2006/main" r:embed="R53ffa55868ce4d95"/>
+          <a:stretch xmlns:a="http://schemas.openxmlformats.org/drawingml/2006/main"/>
         </p:blipFill>
         <p:spPr>
           <a:xfrm xmlns:a="http://schemas.openxmlformats.org/drawingml/2006/main">
-            <a:off x="6115050" y="1819275"/>
-            <a:ext cx="2571750" cy="2952750"/>
+            <a:off x="6115050" y="2553719"/>
+            <a:ext cx="2571750" cy="1483862"/>
           </a:xfrm>
           <a:prstGeom xmlns:a="http://schemas.openxmlformats.org/drawingml/2006/main" prst="roundRect">
             <a:avLst>
@@ -3624,7 +3615,7 @@
           <p:cNvPr id="9" name="">
             <a:extLst xmlns:a="http://schemas.openxmlformats.org/drawingml/2006/main">
               <a:ext uri="{FF2B5EF4-FFF2-40B4-BE49-F238E27FC236}">
-                <a16:creationId xmlns:a16="http://schemas.microsoft.com/office/drawing/2014/main" id="{66CEF4A6-32E0-40B4-9CA8-50481AC3936F}"/>
+                <a16:creationId xmlns:a16="http://schemas.microsoft.com/office/drawing/2014/main" id="{B4C37CE2-A5A2-4615-8366-E60DD1AE1E7B}"/>
               </a:ext>
             </a:extLst>
           </p:cNvPr>
@@ -3664,7 +3655,7 @@
                   <a:srgbClr val="55B8FF"/>
                 </a:solidFill>
               </a:rPr>
-              <a:t>3  EXPLAIN</a:t>
+              <a:t>3  説明</a:t>
             </a:r>
           </a:p>
         </p:txBody>
@@ -3678,16 +3669,13 @@
           <p:nvPr/>
         </p:nvPicPr>
         <p:blipFill>
-          <a:blip xmlns:r="http://schemas.openxmlformats.org/officeDocument/2006/relationships" xmlns:a="http://schemas.openxmlformats.org/drawingml/2006/main" r:embed="R1e3cfee3dd694f59"/>
-          <a:srcRect xmlns:a="http://schemas.openxmlformats.org/drawingml/2006/main" l="24873" t="0" r="24873" b="0"/>
-          <a:stretch xmlns:a="http://schemas.openxmlformats.org/drawingml/2006/main">
-            <a:fillRect l="0" t="0" r="0" b="0"/>
-          </a:stretch>
+          <a:blip xmlns:r="http://schemas.openxmlformats.org/officeDocument/2006/relationships" xmlns:a="http://schemas.openxmlformats.org/drawingml/2006/main" r:embed="Rccd29db9be1a4bbf"/>
+          <a:stretch xmlns:a="http://schemas.openxmlformats.org/drawingml/2006/main"/>
         </p:blipFill>
         <p:spPr>
           <a:xfrm xmlns:a="http://schemas.openxmlformats.org/drawingml/2006/main">
-            <a:off x="8915400" y="1819275"/>
-            <a:ext cx="2571750" cy="2952750"/>
+            <a:off x="8915400" y="2553719"/>
+            <a:ext cx="2571750" cy="1483862"/>
           </a:xfrm>
           <a:prstGeom xmlns:a="http://schemas.openxmlformats.org/drawingml/2006/main" prst="roundRect">
             <a:avLst>
@@ -3701,7 +3689,7 @@
           <p:cNvPr id="11" name="">
             <a:extLst xmlns:a="http://schemas.openxmlformats.org/drawingml/2006/main">
               <a:ext uri="{FF2B5EF4-FFF2-40B4-BE49-F238E27FC236}">
-                <a16:creationId xmlns:a16="http://schemas.microsoft.com/office/drawing/2014/main" id="{C3EEA09E-7F58-4483-8680-6CACE86E41D3}"/>
+                <a16:creationId xmlns:a16="http://schemas.microsoft.com/office/drawing/2014/main" id="{799C28D9-A5F5-4AFF-A5DB-FE3BBE198433}"/>
               </a:ext>
             </a:extLst>
           </p:cNvPr>
@@ -3741,7 +3729,7 @@
                   <a:srgbClr val="69E3CC"/>
                 </a:solidFill>
               </a:rPr>
-              <a:t>4  SHARE</a:t>
+              <a:t>4  共有</a:t>
             </a:r>
           </a:p>
         </p:txBody>
@@ -3751,7 +3739,7 @@
           <p:cNvPr id="12" name="">
             <a:extLst xmlns:a="http://schemas.openxmlformats.org/drawingml/2006/main">
               <a:ext uri="{FF2B5EF4-FFF2-40B4-BE49-F238E27FC236}">
-                <a16:creationId xmlns:a16="http://schemas.microsoft.com/office/drawing/2014/main" id="{303DC890-83ED-4940-84CE-5AA383B9D089}"/>
+                <a16:creationId xmlns:a16="http://schemas.microsoft.com/office/drawing/2014/main" id="{78A12A94-EB22-4720-8A4B-795094395626}"/>
               </a:ext>
             </a:extLst>
           </p:cNvPr>
@@ -3791,7 +3779,7 @@
                   <a:srgbClr val="8AA4AC"/>
                 </a:solidFill>
               </a:rPr>
-              <a:t>profileを変えると、同じ/mnt/cでも説明と優先順位が変わる。</a:t>
+              <a:t>利用目的を変えると、同じ/mnt/cでも説明と優先順位が変わる。</a:t>
             </a:r>
           </a:p>
         </p:txBody>
@@ -3801,7 +3789,7 @@
           <p:cNvPr id="13" name="">
             <a:extLst xmlns:a="http://schemas.openxmlformats.org/drawingml/2006/main">
               <a:ext uri="{FF2B5EF4-FFF2-40B4-BE49-F238E27FC236}">
-                <a16:creationId xmlns:a16="http://schemas.microsoft.com/office/drawing/2014/main" id="{1672CF55-A5C5-433A-A6C5-35B7E3648161}"/>
+                <a16:creationId xmlns:a16="http://schemas.microsoft.com/office/drawing/2014/main" id="{32743B9D-B679-434B-AFA2-517B17D7DE3C}"/>
               </a:ext>
             </a:extLst>
           </p:cNvPr>
@@ -3841,7 +3829,7 @@
                   <a:srgbClr val="F2BD66"/>
                 </a:solidFill>
               </a:rPr>
-              <a:t>Concept UI</a:t>
+              <a:t>コンセプト画面</a:t>
             </a:r>
           </a:p>
         </p:txBody>
@@ -3851,7 +3839,7 @@
           <p:cNvPr id="14" name="">
             <a:extLst xmlns:a="http://schemas.openxmlformats.org/drawingml/2006/main">
               <a:ext uri="{FF2B5EF4-FFF2-40B4-BE49-F238E27FC236}">
-                <a16:creationId xmlns:a16="http://schemas.microsoft.com/office/drawing/2014/main" id="{DA875CFD-72A6-4071-813A-D1EE0AE46176}"/>
+                <a16:creationId xmlns:a16="http://schemas.microsoft.com/office/drawing/2014/main" id="{C5F14A1B-A3E4-42EC-845D-788BCA724A3C}"/>
               </a:ext>
             </a:extLst>
           </p:cNvPr>
@@ -3882,7 +3870,7 @@
           <p:cNvPr id="15" name="">
             <a:extLst xmlns:a="http://schemas.openxmlformats.org/drawingml/2006/main">
               <a:ext uri="{FF2B5EF4-FFF2-40B4-BE49-F238E27FC236}">
-                <a16:creationId xmlns:a16="http://schemas.microsoft.com/office/drawing/2014/main" id="{5A727D1E-5676-4055-8BB6-C6710D09950B}"/>
+                <a16:creationId xmlns:a16="http://schemas.microsoft.com/office/drawing/2014/main" id="{742FA109-C5CD-46D5-8BBB-5CC37AF294CB}"/>
               </a:ext>
             </a:extLst>
           </p:cNvPr>
@@ -3932,7 +3920,7 @@
           <p:cNvPr id="16" name="">
             <a:extLst xmlns:a="http://schemas.openxmlformats.org/drawingml/2006/main">
               <a:ext uri="{FF2B5EF4-FFF2-40B4-BE49-F238E27FC236}">
-                <a16:creationId xmlns:a16="http://schemas.microsoft.com/office/drawing/2014/main" id="{9787D333-79D1-4C11-8719-0910F2E0E81E}"/>
+                <a16:creationId xmlns:a16="http://schemas.microsoft.com/office/drawing/2014/main" id="{7AD32212-210C-4116-993A-9CC07D82E19D}"/>
               </a:ext>
             </a:extLst>
           </p:cNvPr>
@@ -3980,7 +3968,7 @@
     </p:spTree>
     <p:extLst>
       <p:ext uri="{BB962C8B-B14F-4D97-AF65-F5344CB8AC3E}">
-        <p14:creationId xmlns:p14="http://schemas.microsoft.com/office/powerpoint/2010/main" val="338938818"/>
+        <p14:creationId xmlns:p14="http://schemas.microsoft.com/office/powerpoint/2010/main" val="211678947"/>
       </p:ext>
     </p:extLst>
   </p:cSld>
@@ -4011,7 +3999,7 @@
           <p:cNvPr id="20" name="">
             <a:extLst xmlns:a="http://schemas.openxmlformats.org/drawingml/2006/main">
               <a:ext uri="{FF2B5EF4-FFF2-40B4-BE49-F238E27FC236}">
-                <a16:creationId xmlns:a16="http://schemas.microsoft.com/office/drawing/2014/main" id="{0ECF827B-0323-4940-A767-08A3DC3139B5}"/>
+                <a16:creationId xmlns:a16="http://schemas.microsoft.com/office/drawing/2014/main" id="{456BFCD2-8F95-41A4-9EFE-3BB906C1A6B5}"/>
               </a:ext>
             </a:extLst>
           </p:cNvPr>
@@ -4051,7 +4039,7 @@
                   <a:srgbClr val="69E3CC"/>
                 </a:solidFill>
               </a:rPr>
-              <a:t>04 · /mnt/c IS A CHOICE</a:t>
+              <a:t>04 · /mnt/cは選択肢</a:t>
             </a:r>
           </a:p>
         </p:txBody>
@@ -4061,7 +4049,7 @@
           <p:cNvPr id="2" name="">
             <a:extLst xmlns:a="http://schemas.openxmlformats.org/drawingml/2006/main">
               <a:ext uri="{FF2B5EF4-FFF2-40B4-BE49-F238E27FC236}">
-                <a16:creationId xmlns:a16="http://schemas.microsoft.com/office/drawing/2014/main" id="{FFC5D96D-914E-4AC4-9BDD-63C5FE54DF55}"/>
+                <a16:creationId xmlns:a16="http://schemas.microsoft.com/office/drawing/2014/main" id="{C2A14190-91A8-4B1C-925C-132360C3232B}"/>
               </a:ext>
             </a:extLst>
           </p:cNvPr>
@@ -4101,7 +4089,7 @@
                   <a:srgbClr val="8AA4AC"/>
                 </a:solidFill>
               </a:rPr>
-              <a:t>2026.07 · SOURCE PROTOTYPE</a:t>
+              <a:t>2026.07 · ソース版</a:t>
             </a:r>
           </a:p>
         </p:txBody>
@@ -4111,7 +4099,7 @@
           <p:cNvPr id="3" name="">
             <a:extLst xmlns:a="http://schemas.openxmlformats.org/drawingml/2006/main">
               <a:ext uri="{FF2B5EF4-FFF2-40B4-BE49-F238E27FC236}">
-                <a16:creationId xmlns:a16="http://schemas.microsoft.com/office/drawing/2014/main" id="{B0E1DB1B-91B1-461C-B31E-AC0D34D3B951}"/>
+                <a16:creationId xmlns:a16="http://schemas.microsoft.com/office/drawing/2014/main" id="{637BC65C-E3CF-402F-9B5D-78B212E1AC02}"/>
               </a:ext>
             </a:extLst>
           </p:cNvPr>
@@ -4151,7 +4139,7 @@
                   <a:srgbClr val="E7FBF6"/>
                 </a:solidFill>
               </a:rPr>
-              <a:t>/mnt/cはerrorではない。目的との不一致を説明する。</a:t>
+              <a:t>/mnt/cはエラーではない。目的との不一致を説明する。</a:t>
             </a:r>
           </a:p>
         </p:txBody>
@@ -4165,16 +4153,13 @@
           <p:nvPr/>
         </p:nvPicPr>
         <p:blipFill>
-          <a:blip xmlns:r="http://schemas.openxmlformats.org/officeDocument/2006/relationships" xmlns:a="http://schemas.openxmlformats.org/drawingml/2006/main" r:embed="R0f8fa5cba286451d"/>
-          <a:srcRect xmlns:a="http://schemas.openxmlformats.org/drawingml/2006/main" l="12429" t="0" r="12429" b="0"/>
-          <a:stretch xmlns:a="http://schemas.openxmlformats.org/drawingml/2006/main">
-            <a:fillRect l="0" t="0" r="0" b="0"/>
-          </a:stretch>
+          <a:blip xmlns:r="http://schemas.openxmlformats.org/officeDocument/2006/relationships" xmlns:a="http://schemas.openxmlformats.org/drawingml/2006/main" r:embed="R0096d3a585a74a21"/>
+          <a:stretch xmlns:a="http://schemas.openxmlformats.org/drawingml/2006/main"/>
         </p:blipFill>
         <p:spPr>
           <a:xfrm xmlns:a="http://schemas.openxmlformats.org/drawingml/2006/main">
-            <a:off x="6343650" y="1647825"/>
-            <a:ext cx="5334000" cy="4095750"/>
+            <a:off x="6343650" y="2156880"/>
+            <a:ext cx="5334000" cy="3077640"/>
           </a:xfrm>
           <a:prstGeom xmlns:a="http://schemas.openxmlformats.org/drawingml/2006/main" prst="roundRect">
             <a:avLst>
@@ -4188,7 +4173,7 @@
           <p:cNvPr id="5" name="">
             <a:extLst xmlns:a="http://schemas.openxmlformats.org/drawingml/2006/main">
               <a:ext uri="{FF2B5EF4-FFF2-40B4-BE49-F238E27FC236}">
-                <a16:creationId xmlns:a16="http://schemas.microsoft.com/office/drawing/2014/main" id="{62EEBEDD-BEE2-473F-AD7B-0458514E2A01}"/>
+                <a16:creationId xmlns:a16="http://schemas.microsoft.com/office/drawing/2014/main" id="{82194CCA-C42E-4FCA-AFF9-C6063AE6E2A3}"/>
               </a:ext>
             </a:extLst>
           </p:cNvPr>
@@ -4238,7 +4223,7 @@
           <p:cNvPr id="6" name="">
             <a:extLst xmlns:a="http://schemas.openxmlformats.org/drawingml/2006/main">
               <a:ext uri="{FF2B5EF4-FFF2-40B4-BE49-F238E27FC236}">
-                <a16:creationId xmlns:a16="http://schemas.microsoft.com/office/drawing/2014/main" id="{9D5FD749-1EFA-4EBB-AC6D-D106BA43A8EB}"/>
+                <a16:creationId xmlns:a16="http://schemas.microsoft.com/office/drawing/2014/main" id="{97D6D8BF-F79A-4D62-9ADA-3F0F90C90A82}"/>
               </a:ext>
             </a:extLst>
           </p:cNvPr>
@@ -4278,7 +4263,7 @@
                   <a:srgbClr val="69E3CC"/>
                 </a:solidFill>
               </a:rPr>
-              <a:t>EXPECTED</a:t>
+              <a:t>想定内</a:t>
             </a:r>
           </a:p>
         </p:txBody>
@@ -4288,7 +4273,7 @@
           <p:cNvPr id="7" name="">
             <a:extLst xmlns:a="http://schemas.openxmlformats.org/drawingml/2006/main">
               <a:ext uri="{FF2B5EF4-FFF2-40B4-BE49-F238E27FC236}">
-                <a16:creationId xmlns:a16="http://schemas.microsoft.com/office/drawing/2014/main" id="{872A2706-396A-4275-884C-4D9DDD653B71}"/>
+                <a16:creationId xmlns:a16="http://schemas.microsoft.com/office/drawing/2014/main" id="{AC8EB336-9547-4169-AA85-FA2A3CEB63FB}"/>
               </a:ext>
             </a:extLst>
           </p:cNvPr>
@@ -4338,7 +4323,7 @@
           <p:cNvPr id="8" name="">
             <a:extLst xmlns:a="http://schemas.openxmlformats.org/drawingml/2006/main">
               <a:ext uri="{FF2B5EF4-FFF2-40B4-BE49-F238E27FC236}">
-                <a16:creationId xmlns:a16="http://schemas.microsoft.com/office/drawing/2014/main" id="{3B173B2A-0321-407A-845D-FAA957DEBEC9}"/>
+                <a16:creationId xmlns:a16="http://schemas.microsoft.com/office/drawing/2014/main" id="{61E73584-0410-4094-8F22-DE013E720138}"/>
               </a:ext>
             </a:extLst>
           </p:cNvPr>
@@ -4369,7 +4354,7 @@
           <p:cNvPr id="9" name="">
             <a:extLst xmlns:a="http://schemas.openxmlformats.org/drawingml/2006/main">
               <a:ext uri="{FF2B5EF4-FFF2-40B4-BE49-F238E27FC236}">
-                <a16:creationId xmlns:a16="http://schemas.microsoft.com/office/drawing/2014/main" id="{F724365B-433F-492A-97D5-3988585E37E2}"/>
+                <a16:creationId xmlns:a16="http://schemas.microsoft.com/office/drawing/2014/main" id="{9B469E8F-0C92-4A0E-885D-FACDE4911D8E}"/>
               </a:ext>
             </a:extLst>
           </p:cNvPr>
@@ -4419,7 +4404,7 @@
           <p:cNvPr id="10" name="">
             <a:extLst xmlns:a="http://schemas.openxmlformats.org/drawingml/2006/main">
               <a:ext uri="{FF2B5EF4-FFF2-40B4-BE49-F238E27FC236}">
-                <a16:creationId xmlns:a16="http://schemas.microsoft.com/office/drawing/2014/main" id="{F60714ED-4A41-43EB-86CA-4C4C8C095688}"/>
+                <a16:creationId xmlns:a16="http://schemas.microsoft.com/office/drawing/2014/main" id="{A3AF13F8-EE5D-4AC6-BF70-9BA30E837079}"/>
               </a:ext>
             </a:extLst>
           </p:cNvPr>
@@ -4459,7 +4444,7 @@
                   <a:srgbClr val="55B8FF"/>
                 </a:solidFill>
               </a:rPr>
-              <a:t>INFO</a:t>
+              <a:t>情報</a:t>
             </a:r>
           </a:p>
         </p:txBody>
@@ -4469,7 +4454,7 @@
           <p:cNvPr id="11" name="">
             <a:extLst xmlns:a="http://schemas.openxmlformats.org/drawingml/2006/main">
               <a:ext uri="{FF2B5EF4-FFF2-40B4-BE49-F238E27FC236}">
-                <a16:creationId xmlns:a16="http://schemas.microsoft.com/office/drawing/2014/main" id="{AFF59595-F3F6-4CF3-A952-75D1B90E56EF}"/>
+                <a16:creationId xmlns:a16="http://schemas.microsoft.com/office/drawing/2014/main" id="{89B4699F-E7BC-4DF9-AA88-56AD914C8347}"/>
               </a:ext>
             </a:extLst>
           </p:cNvPr>
@@ -4509,7 +4494,7 @@
                   <a:srgbClr val="8AA4AC"/>
                 </a:solidFill>
               </a:rPr>
-              <a:t>共有とLinux toolchainの両方を測定</a:t>
+              <a:t>共有とLinuxツール群の両方を測定</a:t>
             </a:r>
           </a:p>
         </p:txBody>
@@ -4519,7 +4504,7 @@
           <p:cNvPr id="12" name="">
             <a:extLst xmlns:a="http://schemas.openxmlformats.org/drawingml/2006/main">
               <a:ext uri="{FF2B5EF4-FFF2-40B4-BE49-F238E27FC236}">
-                <a16:creationId xmlns:a16="http://schemas.microsoft.com/office/drawing/2014/main" id="{9EA86584-9884-4AD0-80A4-959A025558EA}"/>
+                <a16:creationId xmlns:a16="http://schemas.microsoft.com/office/drawing/2014/main" id="{05643E91-B2D3-4542-8D6F-73EAA7E97E99}"/>
               </a:ext>
             </a:extLst>
           </p:cNvPr>
@@ -4550,7 +4535,7 @@
           <p:cNvPr id="13" name="">
             <a:extLst xmlns:a="http://schemas.openxmlformats.org/drawingml/2006/main">
               <a:ext uri="{FF2B5EF4-FFF2-40B4-BE49-F238E27FC236}">
-                <a16:creationId xmlns:a16="http://schemas.microsoft.com/office/drawing/2014/main" id="{3738C238-5896-45AE-9B82-F89D4597070D}"/>
+                <a16:creationId xmlns:a16="http://schemas.microsoft.com/office/drawing/2014/main" id="{14DB38ED-5299-4133-9E79-5A562940A5CE}"/>
               </a:ext>
             </a:extLst>
           </p:cNvPr>
@@ -4600,7 +4585,7 @@
           <p:cNvPr id="14" name="">
             <a:extLst xmlns:a="http://schemas.openxmlformats.org/drawingml/2006/main">
               <a:ext uri="{FF2B5EF4-FFF2-40B4-BE49-F238E27FC236}">
-                <a16:creationId xmlns:a16="http://schemas.microsoft.com/office/drawing/2014/main" id="{65AA3B84-C51E-4271-AD9C-64F8A3F174ED}"/>
+                <a16:creationId xmlns:a16="http://schemas.microsoft.com/office/drawing/2014/main" id="{8FE9B769-849A-41D2-9FCE-2ED6A7B0E4EE}"/>
               </a:ext>
             </a:extLst>
           </p:cNvPr>
@@ -4640,7 +4625,7 @@
                   <a:srgbClr val="F2BD66"/>
                 </a:solidFill>
               </a:rPr>
-              <a:t>WARNING</a:t>
+              <a:t>警告</a:t>
             </a:r>
           </a:p>
         </p:txBody>
@@ -4650,7 +4635,7 @@
           <p:cNvPr id="15" name="">
             <a:extLst xmlns:a="http://schemas.openxmlformats.org/drawingml/2006/main">
               <a:ext uri="{FF2B5EF4-FFF2-40B4-BE49-F238E27FC236}">
-                <a16:creationId xmlns:a16="http://schemas.microsoft.com/office/drawing/2014/main" id="{E01ADB34-FF6B-43BA-A8CF-AA25E840F553}"/>
+                <a16:creationId xmlns:a16="http://schemas.microsoft.com/office/drawing/2014/main" id="{7C3B5814-0E7C-4DC8-A7BA-F0D5C56B7EBC}"/>
               </a:ext>
             </a:extLst>
           </p:cNvPr>
@@ -4690,7 +4675,7 @@
                   <a:srgbClr val="8AA4AC"/>
                 </a:solidFill>
               </a:rPr>
-              <a:t>Linux-native性能とsemanticsを優先</a:t>
+              <a:t>Linuxネイティブの性能と動作特性を優先</a:t>
             </a:r>
           </a:p>
         </p:txBody>
@@ -4700,7 +4685,7 @@
           <p:cNvPr id="16" name="">
             <a:extLst xmlns:a="http://schemas.openxmlformats.org/drawingml/2006/main">
               <a:ext uri="{FF2B5EF4-FFF2-40B4-BE49-F238E27FC236}">
-                <a16:creationId xmlns:a16="http://schemas.microsoft.com/office/drawing/2014/main" id="{FA6B102F-EB7B-4E35-BB11-49B39D29843B}"/>
+                <a16:creationId xmlns:a16="http://schemas.microsoft.com/office/drawing/2014/main" id="{944782D7-7E6F-45AD-8061-7345198904A3}"/>
               </a:ext>
             </a:extLst>
           </p:cNvPr>
@@ -4750,7 +4735,7 @@
           <p:cNvPr id="17" name="">
             <a:extLst xmlns:a="http://schemas.openxmlformats.org/drawingml/2006/main">
               <a:ext uri="{FF2B5EF4-FFF2-40B4-BE49-F238E27FC236}">
-                <a16:creationId xmlns:a16="http://schemas.microsoft.com/office/drawing/2014/main" id="{98AB7442-723F-4921-967A-7D6F2369C19E}"/>
+                <a16:creationId xmlns:a16="http://schemas.microsoft.com/office/drawing/2014/main" id="{02FDA1DF-0F9A-4C20-A26B-EDF93A7DAFB0}"/>
               </a:ext>
             </a:extLst>
           </p:cNvPr>
@@ -4781,7 +4766,7 @@
           <p:cNvPr id="18" name="">
             <a:extLst xmlns:a="http://schemas.openxmlformats.org/drawingml/2006/main">
               <a:ext uri="{FF2B5EF4-FFF2-40B4-BE49-F238E27FC236}">
-                <a16:creationId xmlns:a16="http://schemas.microsoft.com/office/drawing/2014/main" id="{29319826-7A9E-4950-BCC1-2696E6F85F8C}"/>
+                <a16:creationId xmlns:a16="http://schemas.microsoft.com/office/drawing/2014/main" id="{C9727462-5D46-4FA4-BD31-2111871B33D5}"/>
               </a:ext>
             </a:extLst>
           </p:cNvPr>
@@ -4831,7 +4816,7 @@
           <p:cNvPr id="19" name="">
             <a:extLst xmlns:a="http://schemas.openxmlformats.org/drawingml/2006/main">
               <a:ext uri="{FF2B5EF4-FFF2-40B4-BE49-F238E27FC236}">
-                <a16:creationId xmlns:a16="http://schemas.microsoft.com/office/drawing/2014/main" id="{D32E464E-0228-47E1-98D4-BBE05B857DA8}"/>
+                <a16:creationId xmlns:a16="http://schemas.microsoft.com/office/drawing/2014/main" id="{525E1768-22E2-4CB1-B879-97CC57D9AE76}"/>
               </a:ext>
             </a:extLst>
           </p:cNvPr>
@@ -4879,7 +4864,7 @@
     </p:spTree>
     <p:extLst>
       <p:ext uri="{BB962C8B-B14F-4D97-AF65-F5344CB8AC3E}">
-        <p14:creationId xmlns:p14="http://schemas.microsoft.com/office/powerpoint/2010/main" val="1416690073"/>
+        <p14:creationId xmlns:p14="http://schemas.microsoft.com/office/powerpoint/2010/main" val="726419319"/>
       </p:ext>
     </p:extLst>
   </p:cSld>
@@ -4910,7 +4895,7 @@
           <p:cNvPr id="18" name="">
             <a:extLst xmlns:a="http://schemas.openxmlformats.org/drawingml/2006/main">
               <a:ext uri="{FF2B5EF4-FFF2-40B4-BE49-F238E27FC236}">
-                <a16:creationId xmlns:a16="http://schemas.microsoft.com/office/drawing/2014/main" id="{301DA954-E9F7-4B9F-AD1D-7DC28B555FC3}"/>
+                <a16:creationId xmlns:a16="http://schemas.microsoft.com/office/drawing/2014/main" id="{F33A03A4-1CA4-41EA-BC7E-41105293C149}"/>
               </a:ext>
             </a:extLst>
           </p:cNvPr>
@@ -4950,7 +4935,7 @@
                   <a:srgbClr val="69E3CC"/>
                 </a:solidFill>
               </a:rPr>
-              <a:t>05 · SHARE WITHOUT IDENTITY</a:t>
+              <a:t>05 · 識別情報なしで共有</a:t>
             </a:r>
           </a:p>
         </p:txBody>
@@ -4960,7 +4945,7 @@
           <p:cNvPr id="2" name="">
             <a:extLst xmlns:a="http://schemas.openxmlformats.org/drawingml/2006/main">
               <a:ext uri="{FF2B5EF4-FFF2-40B4-BE49-F238E27FC236}">
-                <a16:creationId xmlns:a16="http://schemas.microsoft.com/office/drawing/2014/main" id="{F7C9122E-D4DB-4C8A-B5EA-01EDAC1A12D3}"/>
+                <a16:creationId xmlns:a16="http://schemas.microsoft.com/office/drawing/2014/main" id="{043E18FE-E854-4B1A-8B1E-1CBBA4A55957}"/>
               </a:ext>
             </a:extLst>
           </p:cNvPr>
@@ -5000,7 +4985,7 @@
                   <a:srgbClr val="8AA4AC"/>
                 </a:solidFill>
               </a:rPr>
-              <a:t>2026.07 · SOURCE PROTOTYPE</a:t>
+              <a:t>2026.07 · ソース版</a:t>
             </a:r>
           </a:p>
         </p:txBody>
@@ -5010,7 +4995,7 @@
           <p:cNvPr id="3" name="">
             <a:extLst xmlns:a="http://schemas.openxmlformats.org/drawingml/2006/main">
               <a:ext uri="{FF2B5EF4-FFF2-40B4-BE49-F238E27FC236}">
-                <a16:creationId xmlns:a16="http://schemas.microsoft.com/office/drawing/2014/main" id="{BE1049BC-5EC2-4C23-A557-67EE543E2844}"/>
+                <a16:creationId xmlns:a16="http://schemas.microsoft.com/office/drawing/2014/main" id="{2567A1BE-EB87-4D20-A4A2-E686A43F3806}"/>
               </a:ext>
             </a:extLst>
           </p:cNvPr>
@@ -5050,7 +5035,7 @@
                   <a:srgbClr val="E7FBF6"/>
                 </a:solidFill>
               </a:rPr>
-              <a:t>共有用reportは、render前に匿名化する。</a:t>
+              <a:t>共有用レポートは、表示前に匿名化する。</a:t>
             </a:r>
           </a:p>
         </p:txBody>
@@ -5064,7 +5049,7 @@
           <p:nvPr/>
         </p:nvPicPr>
         <p:blipFill>
-          <a:blip xmlns:r="http://schemas.openxmlformats.org/officeDocument/2006/relationships" xmlns:a="http://schemas.openxmlformats.org/drawingml/2006/main" r:embed="R5831ad12dc2e46d7"/>
+          <a:blip xmlns:r="http://schemas.openxmlformats.org/officeDocument/2006/relationships" xmlns:a="http://schemas.openxmlformats.org/drawingml/2006/main" r:embed="R6a5e0b704a4d4f3c"/>
           <a:srcRect xmlns:a="http://schemas.openxmlformats.org/drawingml/2006/main" l="352" t="0" r="352" b="0"/>
           <a:stretch xmlns:a="http://schemas.openxmlformats.org/drawingml/2006/main">
             <a:fillRect l="0" t="0" r="0" b="0"/>
@@ -5087,7 +5072,7 @@
           <p:cNvPr id="5" name="">
             <a:extLst xmlns:a="http://schemas.openxmlformats.org/drawingml/2006/main">
               <a:ext uri="{FF2B5EF4-FFF2-40B4-BE49-F238E27FC236}">
-                <a16:creationId xmlns:a16="http://schemas.microsoft.com/office/drawing/2014/main" id="{F5800480-618C-4DFF-84A7-406FAB8639F8}"/>
+                <a16:creationId xmlns:a16="http://schemas.microsoft.com/office/drawing/2014/main" id="{68213C99-EC46-4611-AE3B-F8030672AC9F}"/>
               </a:ext>
             </a:extLst>
           </p:cNvPr>
@@ -5127,7 +5112,7 @@
                   <a:srgbClr val="69E3CC"/>
                 </a:solidFill>
               </a:rPr>
-              <a:t>REDACTED</a:t>
+              <a:t>匿名化済み</a:t>
             </a:r>
           </a:p>
         </p:txBody>
@@ -5137,7 +5122,7 @@
           <p:cNvPr id="6" name="">
             <a:extLst xmlns:a="http://schemas.openxmlformats.org/drawingml/2006/main">
               <a:ext uri="{FF2B5EF4-FFF2-40B4-BE49-F238E27FC236}">
-                <a16:creationId xmlns:a16="http://schemas.microsoft.com/office/drawing/2014/main" id="{AE91DF01-2658-4476-AE52-ACFF21D1CDCC}"/>
+                <a16:creationId xmlns:a16="http://schemas.microsoft.com/office/drawing/2014/main" id="{DB031175-6963-490F-99BF-812270E44E33}"/>
               </a:ext>
             </a:extLst>
           </p:cNvPr>
@@ -5168,7 +5153,7 @@
           <p:cNvPr id="7" name="">
             <a:extLst xmlns:a="http://schemas.openxmlformats.org/drawingml/2006/main">
               <a:ext uri="{FF2B5EF4-FFF2-40B4-BE49-F238E27FC236}">
-                <a16:creationId xmlns:a16="http://schemas.microsoft.com/office/drawing/2014/main" id="{25D81812-F8BD-47D9-A6D0-5BDA9D598268}"/>
+                <a16:creationId xmlns:a16="http://schemas.microsoft.com/office/drawing/2014/main" id="{8C3C5336-DC0D-4D89-8E26-ECBC5847DCB9}"/>
               </a:ext>
             </a:extLst>
           </p:cNvPr>
@@ -5208,7 +5193,7 @@
                   <a:srgbClr val="E7FBF6"/>
                 </a:solidFill>
               </a:rPr>
-              <a:t>username / home</a:t>
+              <a:t>利用者名／ホーム</a:t>
             </a:r>
           </a:p>
         </p:txBody>
@@ -5218,7 +5203,7 @@
           <p:cNvPr id="8" name="">
             <a:extLst xmlns:a="http://schemas.openxmlformats.org/drawingml/2006/main">
               <a:ext uri="{FF2B5EF4-FFF2-40B4-BE49-F238E27FC236}">
-                <a16:creationId xmlns:a16="http://schemas.microsoft.com/office/drawing/2014/main" id="{C7ACAA91-E312-4374-A334-B335E327F58E}"/>
+                <a16:creationId xmlns:a16="http://schemas.microsoft.com/office/drawing/2014/main" id="{C1CDB1B9-3CB9-4A64-8EFE-974D6A5B31AB}"/>
               </a:ext>
             </a:extLst>
           </p:cNvPr>
@@ -5249,7 +5234,7 @@
           <p:cNvPr id="9" name="">
             <a:extLst xmlns:a="http://schemas.openxmlformats.org/drawingml/2006/main">
               <a:ext uri="{FF2B5EF4-FFF2-40B4-BE49-F238E27FC236}">
-                <a16:creationId xmlns:a16="http://schemas.microsoft.com/office/drawing/2014/main" id="{2462B42C-07EB-476D-8FFA-F3F69F9B4C13}"/>
+                <a16:creationId xmlns:a16="http://schemas.microsoft.com/office/drawing/2014/main" id="{558922D0-9B27-41C0-88D3-A7FFEAE18ACD}"/>
               </a:ext>
             </a:extLst>
           </p:cNvPr>
@@ -5289,7 +5274,7 @@
                   <a:srgbClr val="E7FBF6"/>
                 </a:solidFill>
               </a:rPr>
-              <a:t>machine name</a:t>
+              <a:t>マシン名</a:t>
             </a:r>
           </a:p>
         </p:txBody>
@@ -5299,7 +5284,7 @@
           <p:cNvPr id="10" name="">
             <a:extLst xmlns:a="http://schemas.openxmlformats.org/drawingml/2006/main">
               <a:ext uri="{FF2B5EF4-FFF2-40B4-BE49-F238E27FC236}">
-                <a16:creationId xmlns:a16="http://schemas.microsoft.com/office/drawing/2014/main" id="{52ED1059-AB17-4234-B721-5A2E232CF333}"/>
+                <a16:creationId xmlns:a16="http://schemas.microsoft.com/office/drawing/2014/main" id="{C7235B89-BF1D-46E0-A36C-135EAA3B2F84}"/>
               </a:ext>
             </a:extLst>
           </p:cNvPr>
@@ -5330,7 +5315,7 @@
           <p:cNvPr id="11" name="">
             <a:extLst xmlns:a="http://schemas.openxmlformats.org/drawingml/2006/main">
               <a:ext uri="{FF2B5EF4-FFF2-40B4-BE49-F238E27FC236}">
-                <a16:creationId xmlns:a16="http://schemas.microsoft.com/office/drawing/2014/main" id="{EEFD401C-74B2-45E6-B3AA-7FCFC0896EBD}"/>
+                <a16:creationId xmlns:a16="http://schemas.microsoft.com/office/drawing/2014/main" id="{B2D43AF4-41FF-409B-BA86-D9E6D5222876}"/>
               </a:ext>
             </a:extLst>
           </p:cNvPr>
@@ -5370,7 +5355,7 @@
                   <a:srgbClr val="E7FBF6"/>
                 </a:solidFill>
               </a:rPr>
-              <a:t>personal absolute path</a:t>
+              <a:t>個人の絶対パス</a:t>
             </a:r>
           </a:p>
         </p:txBody>
@@ -5380,7 +5365,7 @@
           <p:cNvPr id="12" name="">
             <a:extLst xmlns:a="http://schemas.openxmlformats.org/drawingml/2006/main">
               <a:ext uri="{FF2B5EF4-FFF2-40B4-BE49-F238E27FC236}">
-                <a16:creationId xmlns:a16="http://schemas.microsoft.com/office/drawing/2014/main" id="{AE261156-AE6E-4FA6-8D29-5B093BB1A992}"/>
+                <a16:creationId xmlns:a16="http://schemas.microsoft.com/office/drawing/2014/main" id="{E2259844-5B30-4CEC-9384-786C633EA110}"/>
               </a:ext>
             </a:extLst>
           </p:cNvPr>
@@ -5411,7 +5396,7 @@
           <p:cNvPr id="13" name="">
             <a:extLst xmlns:a="http://schemas.openxmlformats.org/drawingml/2006/main">
               <a:ext uri="{FF2B5EF4-FFF2-40B4-BE49-F238E27FC236}">
-                <a16:creationId xmlns:a16="http://schemas.microsoft.com/office/drawing/2014/main" id="{86A1F60E-12D0-49BA-A170-08EFB8DF19EE}"/>
+                <a16:creationId xmlns:a16="http://schemas.microsoft.com/office/drawing/2014/main" id="{9426CB99-C283-46B8-82AE-FA175EEEFF7A}"/>
               </a:ext>
             </a:extLst>
           </p:cNvPr>
@@ -5451,7 +5436,7 @@
                   <a:srgbClr val="E7FBF6"/>
                 </a:solidFill>
               </a:rPr>
-              <a:t>agent state location</a:t>
+              <a:t>エージェント状態の場所</a:t>
             </a:r>
           </a:p>
         </p:txBody>
@@ -5461,7 +5446,7 @@
           <p:cNvPr id="14" name="">
             <a:extLst xmlns:a="http://schemas.openxmlformats.org/drawingml/2006/main">
               <a:ext uri="{FF2B5EF4-FFF2-40B4-BE49-F238E27FC236}">
-                <a16:creationId xmlns:a16="http://schemas.microsoft.com/office/drawing/2014/main" id="{36549064-79EB-40FF-9E34-D900378FAB5B}"/>
+                <a16:creationId xmlns:a16="http://schemas.microsoft.com/office/drawing/2014/main" id="{4E40DA2A-F98A-4035-9407-73CE2CF1DCEF}"/>
               </a:ext>
             </a:extLst>
           </p:cNvPr>
@@ -5501,7 +5486,7 @@
                   <a:srgbClr val="8AA4AC"/>
                 </a:solidFill>
               </a:rPr>
-              <a:t>通常実行はnetworkへ送信せず、tokenや無制限の環境変数値を収集しません。</a:t>
+              <a:t>通常実行は外部送信せず、トークンや環境変数を無制限に収集しません。</a:t>
             </a:r>
           </a:p>
         </p:txBody>
@@ -5511,7 +5496,7 @@
           <p:cNvPr id="15" name="">
             <a:extLst xmlns:a="http://schemas.openxmlformats.org/drawingml/2006/main">
               <a:ext uri="{FF2B5EF4-FFF2-40B4-BE49-F238E27FC236}">
-                <a16:creationId xmlns:a16="http://schemas.microsoft.com/office/drawing/2014/main" id="{F09DE202-C454-4733-9520-B90E98AC78FD}"/>
+                <a16:creationId xmlns:a16="http://schemas.microsoft.com/office/drawing/2014/main" id="{ECE435D3-601A-4E91-8BB9-BA9D9612A018}"/>
               </a:ext>
             </a:extLst>
           </p:cNvPr>
@@ -5542,7 +5527,7 @@
           <p:cNvPr id="16" name="">
             <a:extLst xmlns:a="http://schemas.openxmlformats.org/drawingml/2006/main">
               <a:ext uri="{FF2B5EF4-FFF2-40B4-BE49-F238E27FC236}">
-                <a16:creationId xmlns:a16="http://schemas.microsoft.com/office/drawing/2014/main" id="{812057BF-3AD9-4B0E-9F15-3F5B43FE3255}"/>
+                <a16:creationId xmlns:a16="http://schemas.microsoft.com/office/drawing/2014/main" id="{4CB56FBA-67C9-4151-8B69-6A650C45ED1A}"/>
               </a:ext>
             </a:extLst>
           </p:cNvPr>
@@ -5592,7 +5577,7 @@
           <p:cNvPr id="17" name="">
             <a:extLst xmlns:a="http://schemas.openxmlformats.org/drawingml/2006/main">
               <a:ext uri="{FF2B5EF4-FFF2-40B4-BE49-F238E27FC236}">
-                <a16:creationId xmlns:a16="http://schemas.microsoft.com/office/drawing/2014/main" id="{4D2B94A2-622A-41BD-91C0-30FE0DEAB3CA}"/>
+                <a16:creationId xmlns:a16="http://schemas.microsoft.com/office/drawing/2014/main" id="{ED19DE14-1B21-404F-A5EA-F2CE300DC289}"/>
               </a:ext>
             </a:extLst>
           </p:cNvPr>
@@ -5640,7 +5625,7 @@
     </p:spTree>
     <p:extLst>
       <p:ext uri="{BB962C8B-B14F-4D97-AF65-F5344CB8AC3E}">
-        <p14:creationId xmlns:p14="http://schemas.microsoft.com/office/powerpoint/2010/main" val="1191152396"/>
+        <p14:creationId xmlns:p14="http://schemas.microsoft.com/office/powerpoint/2010/main" val="41284427"/>
       </p:ext>
     </p:extLst>
   </p:cSld>
@@ -5671,7 +5656,7 @@
           <p:cNvPr id="22" name="">
             <a:extLst xmlns:a="http://schemas.openxmlformats.org/drawingml/2006/main">
               <a:ext uri="{FF2B5EF4-FFF2-40B4-BE49-F238E27FC236}">
-                <a16:creationId xmlns:a16="http://schemas.microsoft.com/office/drawing/2014/main" id="{C6E0C940-B903-4199-9370-886AE5B1E57D}"/>
+                <a16:creationId xmlns:a16="http://schemas.microsoft.com/office/drawing/2014/main" id="{9B1CEFB8-DB81-4CBD-8CC6-AD82A90A24B5}"/>
               </a:ext>
             </a:extLst>
           </p:cNvPr>
@@ -5711,7 +5696,7 @@
                   <a:srgbClr val="69E3CC"/>
                 </a:solidFill>
               </a:rPr>
-              <a:t>06 · NEXT</a:t>
+              <a:t>06 · 次へ</a:t>
             </a:r>
           </a:p>
         </p:txBody>
@@ -5721,7 +5706,7 @@
           <p:cNvPr id="2" name="">
             <a:extLst xmlns:a="http://schemas.openxmlformats.org/drawingml/2006/main">
               <a:ext uri="{FF2B5EF4-FFF2-40B4-BE49-F238E27FC236}">
-                <a16:creationId xmlns:a16="http://schemas.microsoft.com/office/drawing/2014/main" id="{795171DC-6620-45DE-B912-E534A5EF1E42}"/>
+                <a16:creationId xmlns:a16="http://schemas.microsoft.com/office/drawing/2014/main" id="{DCF14089-B400-4428-BDB2-D22EC2A45269}"/>
               </a:ext>
             </a:extLst>
           </p:cNvPr>
@@ -5761,7 +5746,7 @@
                   <a:srgbClr val="8AA4AC"/>
                 </a:solidFill>
               </a:rPr>
-              <a:t>PRE-ALPHA · NO BINARY YET</a:t>
+              <a:t>プレアルファ · 配布ファイルは未公開</a:t>
             </a:r>
           </a:p>
         </p:txBody>
@@ -5771,7 +5756,7 @@
           <p:cNvPr id="3" name="">
             <a:extLst xmlns:a="http://schemas.openxmlformats.org/drawingml/2006/main">
               <a:ext uri="{FF2B5EF4-FFF2-40B4-BE49-F238E27FC236}">
-                <a16:creationId xmlns:a16="http://schemas.microsoft.com/office/drawing/2014/main" id="{9DED3D99-ABD0-4A2D-A884-68A2BAF30163}"/>
+                <a16:creationId xmlns:a16="http://schemas.microsoft.com/office/drawing/2014/main" id="{C8091F42-B72E-4768-B9C2-D2D7919485F0}"/>
               </a:ext>
             </a:extLst>
           </p:cNvPr>
@@ -5811,7 +5796,7 @@
                   <a:srgbClr val="E7FBF6"/>
                 </a:solidFill>
               </a:rPr>
-              <a:t>今はsource prototype。</a:t>
+              <a:t>今はソース版。</a:t>
             </a:r>
           </a:p>
           <a:p xmlns:a="http://schemas.openxmlformats.org/drawingml/2006/main">
@@ -5838,7 +5823,7 @@
           <p:cNvPr id="4" name="">
             <a:extLst xmlns:a="http://schemas.openxmlformats.org/drawingml/2006/main">
               <a:ext uri="{FF2B5EF4-FFF2-40B4-BE49-F238E27FC236}">
-                <a16:creationId xmlns:a16="http://schemas.microsoft.com/office/drawing/2014/main" id="{0B2F6183-B32F-481C-8F65-9E271643D3F0}"/>
+                <a16:creationId xmlns:a16="http://schemas.microsoft.com/office/drawing/2014/main" id="{0FCB0AB6-20CB-4FE5-A8A8-F3FCD5102A09}"/>
               </a:ext>
             </a:extLst>
           </p:cNvPr>
@@ -5873,7 +5858,7 @@
           <p:cNvPr id="5" name="">
             <a:extLst xmlns:a="http://schemas.openxmlformats.org/drawingml/2006/main">
               <a:ext uri="{FF2B5EF4-FFF2-40B4-BE49-F238E27FC236}">
-                <a16:creationId xmlns:a16="http://schemas.microsoft.com/office/drawing/2014/main" id="{1410E13F-793C-4FB6-8C62-163A4B6C7463}"/>
+                <a16:creationId xmlns:a16="http://schemas.microsoft.com/office/drawing/2014/main" id="{1EB8B22A-4CB1-490F-B544-9424D52C3363}"/>
               </a:ext>
             </a:extLst>
           </p:cNvPr>
@@ -5913,7 +5898,7 @@
                   <a:srgbClr val="69E3CC"/>
                 </a:solidFill>
               </a:rPr>
-              <a:t>DONE</a:t>
+              <a:t>完了</a:t>
             </a:r>
           </a:p>
         </p:txBody>
@@ -5923,7 +5908,7 @@
           <p:cNvPr id="6" name="">
             <a:extLst xmlns:a="http://schemas.openxmlformats.org/drawingml/2006/main">
               <a:ext uri="{FF2B5EF4-FFF2-40B4-BE49-F238E27FC236}">
-                <a16:creationId xmlns:a16="http://schemas.microsoft.com/office/drawing/2014/main" id="{0DDE0DA7-74D8-41B9-860D-336B10CFDD08}"/>
+                <a16:creationId xmlns:a16="http://schemas.microsoft.com/office/drawing/2014/main" id="{F8287764-1E5E-4F08-BC4E-06480812D876}"/>
               </a:ext>
             </a:extLst>
           </p:cNvPr>
@@ -5973,7 +5958,7 @@
           <p:cNvPr id="7" name="">
             <a:extLst xmlns:a="http://schemas.openxmlformats.org/drawingml/2006/main">
               <a:ext uri="{FF2B5EF4-FFF2-40B4-BE49-F238E27FC236}">
-                <a16:creationId xmlns:a16="http://schemas.microsoft.com/office/drawing/2014/main" id="{2AF10DB2-FEA8-49BE-883F-C9A975118F41}"/>
+                <a16:creationId xmlns:a16="http://schemas.microsoft.com/office/drawing/2014/main" id="{165E691C-24A8-4F6A-B777-4982CB212336}"/>
               </a:ext>
             </a:extLst>
           </p:cNvPr>
@@ -6013,7 +5998,7 @@
                   <a:srgbClr val="8AA4AC"/>
                 </a:solidFill>
               </a:rPr>
-              <a:t>runtime / profiles / explain / resolver / redaction</a:t>
+              <a:t>実行環境・目的・説明・候補・匿名化</a:t>
             </a:r>
           </a:p>
         </p:txBody>
@@ -6023,7 +6008,7 @@
           <p:cNvPr id="8" name="">
             <a:extLst xmlns:a="http://schemas.openxmlformats.org/drawingml/2006/main">
               <a:ext uri="{FF2B5EF4-FFF2-40B4-BE49-F238E27FC236}">
-                <a16:creationId xmlns:a16="http://schemas.microsoft.com/office/drawing/2014/main" id="{7E2EB907-3AF3-413F-ADDB-FE568CD5B499}"/>
+                <a16:creationId xmlns:a16="http://schemas.microsoft.com/office/drawing/2014/main" id="{77EB23CE-4A71-4FC4-856D-52AC7B5CEDAF}"/>
               </a:ext>
             </a:extLst>
           </p:cNvPr>
@@ -6058,7 +6043,7 @@
           <p:cNvPr id="9" name="">
             <a:extLst xmlns:a="http://schemas.openxmlformats.org/drawingml/2006/main">
               <a:ext uri="{FF2B5EF4-FFF2-40B4-BE49-F238E27FC236}">
-                <a16:creationId xmlns:a16="http://schemas.microsoft.com/office/drawing/2014/main" id="{4C291520-28BF-46C1-A2A1-23831AC8A132}"/>
+                <a16:creationId xmlns:a16="http://schemas.microsoft.com/office/drawing/2014/main" id="{16F1577D-75CE-4472-8F4F-F0A6313AE458}"/>
               </a:ext>
             </a:extLst>
           </p:cNvPr>
@@ -6098,7 +6083,7 @@
                   <a:srgbClr val="55B8FF"/>
                 </a:solidFill>
               </a:rPr>
-              <a:t>NEXT</a:t>
+              <a:t>次</a:t>
             </a:r>
           </a:p>
         </p:txBody>
@@ -6108,7 +6093,7 @@
           <p:cNvPr id="10" name="">
             <a:extLst xmlns:a="http://schemas.openxmlformats.org/drawingml/2006/main">
               <a:ext uri="{FF2B5EF4-FFF2-40B4-BE49-F238E27FC236}">
-                <a16:creationId xmlns:a16="http://schemas.microsoft.com/office/drawing/2014/main" id="{52692538-6338-400B-9256-C30A1595C6E3}"/>
+                <a16:creationId xmlns:a16="http://schemas.microsoft.com/office/drawing/2014/main" id="{31C8A33D-9635-450C-9E21-5B0A5CBA53ED}"/>
               </a:ext>
             </a:extLst>
           </p:cNvPr>
@@ -6158,7 +6143,7 @@
           <p:cNvPr id="11" name="">
             <a:extLst xmlns:a="http://schemas.openxmlformats.org/drawingml/2006/main">
               <a:ext uri="{FF2B5EF4-FFF2-40B4-BE49-F238E27FC236}">
-                <a16:creationId xmlns:a16="http://schemas.microsoft.com/office/drawing/2014/main" id="{393C9CB0-7152-4CDB-A63B-6C5E33B077D7}"/>
+                <a16:creationId xmlns:a16="http://schemas.microsoft.com/office/drawing/2014/main" id="{F448B24A-873D-4D20-A8FB-965FE1605C61}"/>
               </a:ext>
             </a:extLst>
           </p:cNvPr>
@@ -6208,7 +6193,7 @@
           <p:cNvPr id="12" name="">
             <a:extLst xmlns:a="http://schemas.openxmlformats.org/drawingml/2006/main">
               <a:ext uri="{FF2B5EF4-FFF2-40B4-BE49-F238E27FC236}">
-                <a16:creationId xmlns:a16="http://schemas.microsoft.com/office/drawing/2014/main" id="{58E6336D-E63E-4924-9914-BA2521898C80}"/>
+                <a16:creationId xmlns:a16="http://schemas.microsoft.com/office/drawing/2014/main" id="{649A9738-F436-492B-B4B3-82F3076E8EF2}"/>
               </a:ext>
             </a:extLst>
           </p:cNvPr>
@@ -6243,7 +6228,7 @@
           <p:cNvPr id="13" name="">
             <a:extLst xmlns:a="http://schemas.openxmlformats.org/drawingml/2006/main">
               <a:ext uri="{FF2B5EF4-FFF2-40B4-BE49-F238E27FC236}">
-                <a16:creationId xmlns:a16="http://schemas.microsoft.com/office/drawing/2014/main" id="{3E6134FD-F980-4AB5-AA33-C7502954A753}"/>
+                <a16:creationId xmlns:a16="http://schemas.microsoft.com/office/drawing/2014/main" id="{5B3D2F06-6DDD-43C7-B88F-CF1C97B1A0AD}"/>
               </a:ext>
             </a:extLst>
           </p:cNvPr>
@@ -6283,7 +6268,7 @@
                   <a:srgbClr val="F2BD66"/>
                 </a:solidFill>
               </a:rPr>
-              <a:t>RELEASE</a:t>
+              <a:t>公開</a:t>
             </a:r>
           </a:p>
         </p:txBody>
@@ -6293,7 +6278,7 @@
           <p:cNvPr id="14" name="">
             <a:extLst xmlns:a="http://schemas.openxmlformats.org/drawingml/2006/main">
               <a:ext uri="{FF2B5EF4-FFF2-40B4-BE49-F238E27FC236}">
-                <a16:creationId xmlns:a16="http://schemas.microsoft.com/office/drawing/2014/main" id="{9D2C3E4D-1B89-46B4-B6DF-53338EAC592D}"/>
+                <a16:creationId xmlns:a16="http://schemas.microsoft.com/office/drawing/2014/main" id="{7D6BECF1-AA9B-44BF-B170-76CFCDA1A201}"/>
               </a:ext>
             </a:extLst>
           </p:cNvPr>
@@ -6343,7 +6328,7 @@
           <p:cNvPr id="15" name="">
             <a:extLst xmlns:a="http://schemas.openxmlformats.org/drawingml/2006/main">
               <a:ext uri="{FF2B5EF4-FFF2-40B4-BE49-F238E27FC236}">
-                <a16:creationId xmlns:a16="http://schemas.microsoft.com/office/drawing/2014/main" id="{A8150071-2E56-47D8-B5A6-5C974F53507E}"/>
+                <a16:creationId xmlns:a16="http://schemas.microsoft.com/office/drawing/2014/main" id="{D069661C-B13C-4410-B906-64D76C8BBFBA}"/>
               </a:ext>
             </a:extLst>
           </p:cNvPr>
@@ -6383,7 +6368,7 @@
                   <a:srgbClr val="8AA4AC"/>
                 </a:solidFill>
               </a:rPr>
-              <a:t>Windows / Linux binary + checksum</a:t>
+              <a:t>Windows／Linux版＋チェックサム</a:t>
             </a:r>
           </a:p>
         </p:txBody>
@@ -6393,7 +6378,7 @@
           <p:cNvPr id="16" name="">
             <a:extLst xmlns:a="http://schemas.openxmlformats.org/drawingml/2006/main">
               <a:ext uri="{FF2B5EF4-FFF2-40B4-BE49-F238E27FC236}">
-                <a16:creationId xmlns:a16="http://schemas.microsoft.com/office/drawing/2014/main" id="{8609DE2F-03CE-49DB-9712-B9EAF12E1F4E}"/>
+                <a16:creationId xmlns:a16="http://schemas.microsoft.com/office/drawing/2014/main" id="{E2767A54-41D7-4F45-AFA1-CAB011F8FC76}"/>
               </a:ext>
             </a:extLst>
           </p:cNvPr>
@@ -6433,7 +6418,7 @@
                   <a:srgbClr val="E7FBF6"/>
                 </a:solidFill>
               </a:rPr>
-              <a:t>困った経験・使っている確認command・prototypeの違和感をIssueへ。</a:t>
+              <a:t>困った経験・使っている確認コマンド・プロトタイプの違和感をIssueへ。</a:t>
             </a:r>
           </a:p>
         </p:txBody>
@@ -6443,7 +6428,7 @@
           <p:cNvPr id="17" name="">
             <a:extLst xmlns:a="http://schemas.openxmlformats.org/drawingml/2006/main">
               <a:ext uri="{FF2B5EF4-FFF2-40B4-BE49-F238E27FC236}">
-                <a16:creationId xmlns:a16="http://schemas.microsoft.com/office/drawing/2014/main" id="{8BF8002B-4F2A-405C-8551-FDA9C309717D}"/>
+                <a16:creationId xmlns:a16="http://schemas.microsoft.com/office/drawing/2014/main" id="{09A9DDA8-4A26-44AC-93FB-F6F1900E4D8A}"/>
               </a:ext>
             </a:extLst>
           </p:cNvPr>
@@ -6493,7 +6478,7 @@
           <p:cNvPr id="18" name="">
             <a:extLst xmlns:a="http://schemas.openxmlformats.org/drawingml/2006/main">
               <a:ext uri="{FF2B5EF4-FFF2-40B4-BE49-F238E27FC236}">
-                <a16:creationId xmlns:a16="http://schemas.microsoft.com/office/drawing/2014/main" id="{376F7EF2-B272-47CD-B706-7280B53C5907}"/>
+                <a16:creationId xmlns:a16="http://schemas.microsoft.com/office/drawing/2014/main" id="{6049B081-8B36-43AE-920F-ED045ED20FFD}"/>
               </a:ext>
             </a:extLst>
           </p:cNvPr>
@@ -6533,7 +6518,7 @@
                   <a:srgbClr val="55B8FF"/>
                 </a:solidFill>
               </a:rPr>
-              <a:t>Star / Watch / Field report</a:t>
+              <a:t>スター／Watch／検証報告</a:t>
             </a:r>
           </a:p>
         </p:txBody>
@@ -6543,7 +6528,7 @@
           <p:cNvPr id="19" name="">
             <a:extLst xmlns:a="http://schemas.openxmlformats.org/drawingml/2006/main">
               <a:ext uri="{FF2B5EF4-FFF2-40B4-BE49-F238E27FC236}">
-                <a16:creationId xmlns:a16="http://schemas.microsoft.com/office/drawing/2014/main" id="{815B0790-5DD1-4940-A2EB-AFC208866798}"/>
+                <a16:creationId xmlns:a16="http://schemas.microsoft.com/office/drawing/2014/main" id="{C351FFC4-CD39-4D52-96BC-DC88A9D9706C}"/>
               </a:ext>
             </a:extLst>
           </p:cNvPr>
@@ -6574,7 +6559,7 @@
           <p:cNvPr id="20" name="">
             <a:extLst xmlns:a="http://schemas.openxmlformats.org/drawingml/2006/main">
               <a:ext uri="{FF2B5EF4-FFF2-40B4-BE49-F238E27FC236}">
-                <a16:creationId xmlns:a16="http://schemas.microsoft.com/office/drawing/2014/main" id="{641A8519-9230-4318-AF73-378D9650DBF5}"/>
+                <a16:creationId xmlns:a16="http://schemas.microsoft.com/office/drawing/2014/main" id="{83F8AA15-06FB-4041-98E3-58F0A5C943C8}"/>
               </a:ext>
             </a:extLst>
           </p:cNvPr>
@@ -6624,7 +6609,7 @@
           <p:cNvPr id="21" name="">
             <a:extLst xmlns:a="http://schemas.openxmlformats.org/drawingml/2006/main">
               <a:ext uri="{FF2B5EF4-FFF2-40B4-BE49-F238E27FC236}">
-                <a16:creationId xmlns:a16="http://schemas.microsoft.com/office/drawing/2014/main" id="{64C040BA-F41B-4900-ABC3-39D86972D665}"/>
+                <a16:creationId xmlns:a16="http://schemas.microsoft.com/office/drawing/2014/main" id="{B44F50D3-B6CA-49D3-99C7-96A482867355}"/>
               </a:ext>
             </a:extLst>
           </p:cNvPr>
@@ -6672,7 +6657,7 @@
     </p:spTree>
     <p:extLst>
       <p:ext uri="{BB962C8B-B14F-4D97-AF65-F5344CB8AC3E}">
-        <p14:creationId xmlns:p14="http://schemas.microsoft.com/office/powerpoint/2010/main" val="1860291063"/>
+        <p14:creationId xmlns:p14="http://schemas.microsoft.com/office/powerpoint/2010/main" val="1444789245"/>
       </p:ext>
     </p:extLst>
   </p:cSld>

</xml_diff>

<commit_message>
docs: animate approved otter poses
</commit_message>
<xml_diff>
--- a/docs/demo/ExecLocus_intro_ja.pptx
+++ b/docs/demo/ExecLocus_intro_ja.pptx
@@ -2,19 +2,19 @@
 <file path=ppt/presentation.xml><?xml version="1.0" encoding="utf-8"?>
 <p:presentation xmlns:p="http://schemas.openxmlformats.org/presentationml/2006/main">
   <p:sldMasterIdLst>
-    <p:sldMasterId xmlns:r="http://schemas.openxmlformats.org/officeDocument/2006/relationships" id="2147483648" r:id="Rbac3b374641a49ed"/>
+    <p:sldMasterId xmlns:r="http://schemas.openxmlformats.org/officeDocument/2006/relationships" id="2147483648" r:id="Rc65c5ca29ebc4383"/>
   </p:sldMasterIdLst>
   <p:notesMasterIdLst>
-    <p:notesMasterId xmlns:r="http://schemas.openxmlformats.org/officeDocument/2006/relationships" r:id="R65fc9b072f744d8b"/>
+    <p:notesMasterId xmlns:r="http://schemas.openxmlformats.org/officeDocument/2006/relationships" r:id="Rdc4933c752cb4e48"/>
   </p:notesMasterIdLst>
   <p:sldIdLst>
-    <p:sldId xmlns:r="http://schemas.openxmlformats.org/officeDocument/2006/relationships" id="256" r:id="R10582b3634d64f84"/>
-    <p:sldId xmlns:r="http://schemas.openxmlformats.org/officeDocument/2006/relationships" id="257" r:id="Rf80099a4671e4a5f"/>
-    <p:sldId xmlns:r="http://schemas.openxmlformats.org/officeDocument/2006/relationships" id="258" r:id="Rf1454e5b9ff441c3"/>
-    <p:sldId xmlns:r="http://schemas.openxmlformats.org/officeDocument/2006/relationships" id="259" r:id="R734d7be321644adf"/>
-    <p:sldId xmlns:r="http://schemas.openxmlformats.org/officeDocument/2006/relationships" id="260" r:id="R8121148f2a2245e5"/>
-    <p:sldId xmlns:r="http://schemas.openxmlformats.org/officeDocument/2006/relationships" id="261" r:id="Rabf1559796954bce"/>
-    <p:sldId xmlns:r="http://schemas.openxmlformats.org/officeDocument/2006/relationships" id="262" r:id="R468ebe803cd44381"/>
+    <p:sldId xmlns:r="http://schemas.openxmlformats.org/officeDocument/2006/relationships" id="256" r:id="R1f6e5509a5044185"/>
+    <p:sldId xmlns:r="http://schemas.openxmlformats.org/officeDocument/2006/relationships" id="257" r:id="R97f8788189ff486f"/>
+    <p:sldId xmlns:r="http://schemas.openxmlformats.org/officeDocument/2006/relationships" id="258" r:id="Rd08e21cc0c8245e5"/>
+    <p:sldId xmlns:r="http://schemas.openxmlformats.org/officeDocument/2006/relationships" id="259" r:id="Rb317b2708eb94fd8"/>
+    <p:sldId xmlns:r="http://schemas.openxmlformats.org/officeDocument/2006/relationships" id="260" r:id="R26d81a316b84467a"/>
+    <p:sldId xmlns:r="http://schemas.openxmlformats.org/officeDocument/2006/relationships" id="261" r:id="R225f73e0bd004ed9"/>
+    <p:sldId xmlns:r="http://schemas.openxmlformats.org/officeDocument/2006/relationships" id="262" r:id="R8dc1c537ceb647f5"/>
   </p:sldIdLst>
   <p:sldSz cx="12192000" cy="6858000"/>
   <p:notesSz cx="6858000" cy="9144000"/>
@@ -1006,7 +1006,7 @@
   </p:cSld>
   <p:clrMap bg1="lt1" tx1="dk1" bg2="lt2" tx2="dk2" accent1="accent1" accent2="accent2" accent3="accent3" accent4="accent4" accent5="accent5" accent6="accent6" hlink="hlink" folHlink="folHlink"/>
   <p:sldLayoutIdLst>
-    <p:sldLayoutId xmlns:r="http://schemas.openxmlformats.org/officeDocument/2006/relationships" id="2147483649" r:id="Rc0cbd01a22194dd6"/>
+    <p:sldLayoutId xmlns:r="http://schemas.openxmlformats.org/officeDocument/2006/relationships" id="2147483649" r:id="R65dc000f09a94f2c"/>
   </p:sldLayoutIdLst>
   <p:txStyles>
     <p:titleStyle>
@@ -1557,7 +1557,7 @@
           <p:cNvPr id="9" name="">
             <a:extLst xmlns:a="http://schemas.openxmlformats.org/drawingml/2006/main">
               <a:ext uri="{FF2B5EF4-FFF2-40B4-BE49-F238E27FC236}">
-                <a16:creationId xmlns:a16="http://schemas.microsoft.com/office/drawing/2014/main" id="{6A569C68-589B-415A-B62F-CE27015BB0FF}"/>
+                <a16:creationId xmlns:a16="http://schemas.microsoft.com/office/drawing/2014/main" id="{FE37E8F2-DFF0-4F48-976D-B2611D7037F9}"/>
               </a:ext>
             </a:extLst>
           </p:cNvPr>
@@ -1596,7 +1596,7 @@
           <p:nvPr/>
         </p:nvPicPr>
         <p:blipFill>
-          <a:blip xmlns:r="http://schemas.openxmlformats.org/officeDocument/2006/relationships" xmlns:a="http://schemas.openxmlformats.org/drawingml/2006/main" r:embed="R32646ef5fc2f4dba"/>
+          <a:blip xmlns:r="http://schemas.openxmlformats.org/officeDocument/2006/relationships" xmlns:a="http://schemas.openxmlformats.org/drawingml/2006/main" r:embed="R9a475a30f26f4d61"/>
           <a:stretch xmlns:a="http://schemas.openxmlformats.org/drawingml/2006/main"/>
         </p:blipFill>
         <p:spPr>
@@ -1616,7 +1616,7 @@
           <p:cNvPr id="3" name="">
             <a:extLst xmlns:a="http://schemas.openxmlformats.org/drawingml/2006/main">
               <a:ext uri="{FF2B5EF4-FFF2-40B4-BE49-F238E27FC236}">
-                <a16:creationId xmlns:a16="http://schemas.microsoft.com/office/drawing/2014/main" id="{79F5C337-603D-4A8C-AB5C-04D9102BFFCA}"/>
+                <a16:creationId xmlns:a16="http://schemas.microsoft.com/office/drawing/2014/main" id="{DA108CB7-8DCB-42CD-AA4C-C5D64813C928}"/>
               </a:ext>
             </a:extLst>
           </p:cNvPr>
@@ -1647,7 +1647,7 @@
           <p:cNvPr id="4" name="">
             <a:extLst xmlns:a="http://schemas.openxmlformats.org/drawingml/2006/main">
               <a:ext uri="{FF2B5EF4-FFF2-40B4-BE49-F238E27FC236}">
-                <a16:creationId xmlns:a16="http://schemas.microsoft.com/office/drawing/2014/main" id="{F60EF9D9-9009-407E-814B-0B29BE96CB37}"/>
+                <a16:creationId xmlns:a16="http://schemas.microsoft.com/office/drawing/2014/main" id="{9153FE22-367C-4DF2-BE02-2CEEC9AE4F65}"/>
               </a:ext>
             </a:extLst>
           </p:cNvPr>
@@ -1697,7 +1697,7 @@
           <p:cNvPr id="5" name="">
             <a:extLst xmlns:a="http://schemas.openxmlformats.org/drawingml/2006/main">
               <a:ext uri="{FF2B5EF4-FFF2-40B4-BE49-F238E27FC236}">
-                <a16:creationId xmlns:a16="http://schemas.microsoft.com/office/drawing/2014/main" id="{89557E7D-A40E-4F14-9E9B-392AD4F3513C}"/>
+                <a16:creationId xmlns:a16="http://schemas.microsoft.com/office/drawing/2014/main" id="{5F316C95-CF02-4C5E-BD1C-DFD35E555379}"/>
               </a:ext>
             </a:extLst>
           </p:cNvPr>
@@ -1764,7 +1764,7 @@
           <p:cNvPr id="6" name="">
             <a:extLst xmlns:a="http://schemas.openxmlformats.org/drawingml/2006/main">
               <a:ext uri="{FF2B5EF4-FFF2-40B4-BE49-F238E27FC236}">
-                <a16:creationId xmlns:a16="http://schemas.microsoft.com/office/drawing/2014/main" id="{D5BE8A7A-F7E8-4A16-B080-D5589BDAEE10}"/>
+                <a16:creationId xmlns:a16="http://schemas.microsoft.com/office/drawing/2014/main" id="{45283139-D07C-4C85-B5D4-6CCF3A1BE1F4}"/>
               </a:ext>
             </a:extLst>
           </p:cNvPr>
@@ -1831,7 +1831,7 @@
           <p:cNvPr id="7" name="">
             <a:extLst xmlns:a="http://schemas.openxmlformats.org/drawingml/2006/main">
               <a:ext uri="{FF2B5EF4-FFF2-40B4-BE49-F238E27FC236}">
-                <a16:creationId xmlns:a16="http://schemas.microsoft.com/office/drawing/2014/main" id="{DF26695E-118E-4092-987A-2AE96C50CC0F}"/>
+                <a16:creationId xmlns:a16="http://schemas.microsoft.com/office/drawing/2014/main" id="{F36E7F93-D049-45DB-82CB-CF87F3C0A710}"/>
               </a:ext>
             </a:extLst>
           </p:cNvPr>
@@ -1881,7 +1881,7 @@
           <p:cNvPr id="8" name="">
             <a:extLst xmlns:a="http://schemas.openxmlformats.org/drawingml/2006/main">
               <a:ext uri="{FF2B5EF4-FFF2-40B4-BE49-F238E27FC236}">
-                <a16:creationId xmlns:a16="http://schemas.microsoft.com/office/drawing/2014/main" id="{EA13CE1A-CEA7-4573-B474-C3DA3F33A886}"/>
+                <a16:creationId xmlns:a16="http://schemas.microsoft.com/office/drawing/2014/main" id="{B6376DA9-AAC9-46F9-890B-FAF2E8C19E55}"/>
               </a:ext>
             </a:extLst>
           </p:cNvPr>
@@ -1929,7 +1929,7 @@
     </p:spTree>
     <p:extLst>
       <p:ext uri="{BB962C8B-B14F-4D97-AF65-F5344CB8AC3E}">
-        <p14:creationId xmlns:p14="http://schemas.microsoft.com/office/powerpoint/2010/main" val="129938683"/>
+        <p14:creationId xmlns:p14="http://schemas.microsoft.com/office/powerpoint/2010/main" val="2002498527"/>
       </p:ext>
     </p:extLst>
   </p:cSld>
@@ -1960,7 +1960,7 @@
           <p:cNvPr id="9" name="">
             <a:extLst xmlns:a="http://schemas.openxmlformats.org/drawingml/2006/main">
               <a:ext uri="{FF2B5EF4-FFF2-40B4-BE49-F238E27FC236}">
-                <a16:creationId xmlns:a16="http://schemas.microsoft.com/office/drawing/2014/main" id="{C2F8E3BD-FD3F-4F41-A8A3-167878352213}"/>
+                <a16:creationId xmlns:a16="http://schemas.microsoft.com/office/drawing/2014/main" id="{66BB88D7-8ABE-4CD6-AAD1-54B2FC783BED}"/>
               </a:ext>
             </a:extLst>
           </p:cNvPr>
@@ -2010,7 +2010,7 @@
           <p:cNvPr id="2" name="">
             <a:extLst xmlns:a="http://schemas.openxmlformats.org/drawingml/2006/main">
               <a:ext uri="{FF2B5EF4-FFF2-40B4-BE49-F238E27FC236}">
-                <a16:creationId xmlns:a16="http://schemas.microsoft.com/office/drawing/2014/main" id="{CCFB69B4-F2CC-4BCB-8B6C-7C908D6A613D}"/>
+                <a16:creationId xmlns:a16="http://schemas.microsoft.com/office/drawing/2014/main" id="{C4EE6E60-EF28-4FA5-B66A-037E2ABED6BC}"/>
               </a:ext>
             </a:extLst>
           </p:cNvPr>
@@ -2060,7 +2060,7 @@
           <p:cNvPr id="3" name="">
             <a:extLst xmlns:a="http://schemas.openxmlformats.org/drawingml/2006/main">
               <a:ext uri="{FF2B5EF4-FFF2-40B4-BE49-F238E27FC236}">
-                <a16:creationId xmlns:a16="http://schemas.microsoft.com/office/drawing/2014/main" id="{2B53260A-D3FC-4A51-984E-75D80A645833}"/>
+                <a16:creationId xmlns:a16="http://schemas.microsoft.com/office/drawing/2014/main" id="{D7F538DF-2715-4114-8A0A-4B0EEE9BB29C}"/>
               </a:ext>
             </a:extLst>
           </p:cNvPr>
@@ -2110,7 +2110,7 @@
           <p:cNvPr id="4" name="">
             <a:extLst xmlns:a="http://schemas.openxmlformats.org/drawingml/2006/main">
               <a:ext uri="{FF2B5EF4-FFF2-40B4-BE49-F238E27FC236}">
-                <a16:creationId xmlns:a16="http://schemas.microsoft.com/office/drawing/2014/main" id="{8483EB6A-F3A6-46D5-BE57-FE6053928A86}"/>
+                <a16:creationId xmlns:a16="http://schemas.microsoft.com/office/drawing/2014/main" id="{226AA24F-0B15-4A48-8FA0-EB8F73EABD67}"/>
               </a:ext>
             </a:extLst>
           </p:cNvPr>
@@ -2164,7 +2164,7 @@
           <p:nvPr/>
         </p:nvPicPr>
         <p:blipFill>
-          <a:blip xmlns:r="http://schemas.openxmlformats.org/officeDocument/2006/relationships" xmlns:a="http://schemas.openxmlformats.org/drawingml/2006/main" r:embed="R92d2f6e640824ea0"/>
+          <a:blip xmlns:r="http://schemas.openxmlformats.org/officeDocument/2006/relationships" xmlns:a="http://schemas.openxmlformats.org/drawingml/2006/main" r:embed="R2d585048366b4f13"/>
           <a:srcRect xmlns:a="http://schemas.openxmlformats.org/drawingml/2006/main" l="0" t="17467" r="0" b="17467"/>
           <a:stretch xmlns:a="http://schemas.openxmlformats.org/drawingml/2006/main">
             <a:fillRect l="0" t="0" r="0" b="0"/>
@@ -2187,7 +2187,7 @@
           <p:cNvPr id="6" name="">
             <a:extLst xmlns:a="http://schemas.openxmlformats.org/drawingml/2006/main">
               <a:ext uri="{FF2B5EF4-FFF2-40B4-BE49-F238E27FC236}">
-                <a16:creationId xmlns:a16="http://schemas.microsoft.com/office/drawing/2014/main" id="{8211BB3A-F091-4DD6-84C7-B423020E3913}"/>
+                <a16:creationId xmlns:a16="http://schemas.microsoft.com/office/drawing/2014/main" id="{B1145022-A9C2-48DF-B9FC-D53C86F19333}"/>
               </a:ext>
             </a:extLst>
           </p:cNvPr>
@@ -2218,7 +2218,7 @@
           <p:cNvPr id="7" name="">
             <a:extLst xmlns:a="http://schemas.openxmlformats.org/drawingml/2006/main">
               <a:ext uri="{FF2B5EF4-FFF2-40B4-BE49-F238E27FC236}">
-                <a16:creationId xmlns:a16="http://schemas.microsoft.com/office/drawing/2014/main" id="{AF0645B2-5864-44DD-A76C-1B1C5B6B3570}"/>
+                <a16:creationId xmlns:a16="http://schemas.microsoft.com/office/drawing/2014/main" id="{131DE7F3-2259-4ADB-BA5F-950F5D75B1D3}"/>
               </a:ext>
             </a:extLst>
           </p:cNvPr>
@@ -2268,7 +2268,7 @@
           <p:cNvPr id="8" name="">
             <a:extLst xmlns:a="http://schemas.openxmlformats.org/drawingml/2006/main">
               <a:ext uri="{FF2B5EF4-FFF2-40B4-BE49-F238E27FC236}">
-                <a16:creationId xmlns:a16="http://schemas.microsoft.com/office/drawing/2014/main" id="{C2AD2AF8-F74F-4674-9D86-22B9A21A9676}"/>
+                <a16:creationId xmlns:a16="http://schemas.microsoft.com/office/drawing/2014/main" id="{15B16C09-C768-435D-B4AA-BEF1738F655B}"/>
               </a:ext>
             </a:extLst>
           </p:cNvPr>
@@ -2316,7 +2316,7 @@
     </p:spTree>
     <p:extLst>
       <p:ext uri="{BB962C8B-B14F-4D97-AF65-F5344CB8AC3E}">
-        <p14:creationId xmlns:p14="http://schemas.microsoft.com/office/powerpoint/2010/main" val="1726707143"/>
+        <p14:creationId xmlns:p14="http://schemas.microsoft.com/office/powerpoint/2010/main" val="408875286"/>
       </p:ext>
     </p:extLst>
   </p:cSld>
@@ -2347,7 +2347,7 @@
           <p:cNvPr id="21" name="">
             <a:extLst xmlns:a="http://schemas.openxmlformats.org/drawingml/2006/main">
               <a:ext uri="{FF2B5EF4-FFF2-40B4-BE49-F238E27FC236}">
-                <a16:creationId xmlns:a16="http://schemas.microsoft.com/office/drawing/2014/main" id="{6DEC9755-740F-4ADA-814E-9511A1658B11}"/>
+                <a16:creationId xmlns:a16="http://schemas.microsoft.com/office/drawing/2014/main" id="{E58B1D1D-8BF9-45CB-8CD0-C464994A43BC}"/>
               </a:ext>
             </a:extLst>
           </p:cNvPr>
@@ -2397,7 +2397,7 @@
           <p:cNvPr id="2" name="">
             <a:extLst xmlns:a="http://schemas.openxmlformats.org/drawingml/2006/main">
               <a:ext uri="{FF2B5EF4-FFF2-40B4-BE49-F238E27FC236}">
-                <a16:creationId xmlns:a16="http://schemas.microsoft.com/office/drawing/2014/main" id="{D8B887D6-2CD6-4D26-B96B-A6454EC0D468}"/>
+                <a16:creationId xmlns:a16="http://schemas.microsoft.com/office/drawing/2014/main" id="{A84FBA48-0DDA-4446-BF14-DB609CFBBAC2}"/>
               </a:ext>
             </a:extLst>
           </p:cNvPr>
@@ -2447,7 +2447,7 @@
           <p:cNvPr id="3" name="">
             <a:extLst xmlns:a="http://schemas.openxmlformats.org/drawingml/2006/main">
               <a:ext uri="{FF2B5EF4-FFF2-40B4-BE49-F238E27FC236}">
-                <a16:creationId xmlns:a16="http://schemas.microsoft.com/office/drawing/2014/main" id="{AF3B3FE5-868F-41F1-AE37-D3A13D4FCA8C}"/>
+                <a16:creationId xmlns:a16="http://schemas.microsoft.com/office/drawing/2014/main" id="{3335808D-7A67-4E58-9FCB-E19539F9F495}"/>
               </a:ext>
             </a:extLst>
           </p:cNvPr>
@@ -2497,7 +2497,7 @@
           <p:cNvPr id="4" name="">
             <a:extLst xmlns:a="http://schemas.openxmlformats.org/drawingml/2006/main">
               <a:ext uri="{FF2B5EF4-FFF2-40B4-BE49-F238E27FC236}">
-                <a16:creationId xmlns:a16="http://schemas.microsoft.com/office/drawing/2014/main" id="{611F7BAE-47BD-4225-9B06-9BE44CC0B869}"/>
+                <a16:creationId xmlns:a16="http://schemas.microsoft.com/office/drawing/2014/main" id="{E51D74BF-FC8B-41A5-AE7A-AC22A7BC3C13}"/>
               </a:ext>
             </a:extLst>
           </p:cNvPr>
@@ -2528,7 +2528,7 @@
           <p:cNvPr id="5" name="">
             <a:extLst xmlns:a="http://schemas.openxmlformats.org/drawingml/2006/main">
               <a:ext uri="{FF2B5EF4-FFF2-40B4-BE49-F238E27FC236}">
-                <a16:creationId xmlns:a16="http://schemas.microsoft.com/office/drawing/2014/main" id="{AC573A77-8B02-4681-9EB6-8F961B119C4B}"/>
+                <a16:creationId xmlns:a16="http://schemas.microsoft.com/office/drawing/2014/main" id="{9AFA51E0-E383-4EE0-86DE-56EDDEC1423F}"/>
               </a:ext>
             </a:extLst>
           </p:cNvPr>
@@ -2563,7 +2563,7 @@
           <p:cNvPr id="6" name="">
             <a:extLst xmlns:a="http://schemas.openxmlformats.org/drawingml/2006/main">
               <a:ext uri="{FF2B5EF4-FFF2-40B4-BE49-F238E27FC236}">
-                <a16:creationId xmlns:a16="http://schemas.microsoft.com/office/drawing/2014/main" id="{2B1393EB-59E1-4603-A40B-FDC4C827989A}"/>
+                <a16:creationId xmlns:a16="http://schemas.microsoft.com/office/drawing/2014/main" id="{140E885F-11FF-4843-A48B-7C78C3C037B7}"/>
               </a:ext>
             </a:extLst>
           </p:cNvPr>
@@ -2613,7 +2613,7 @@
           <p:cNvPr id="7" name="">
             <a:extLst xmlns:a="http://schemas.openxmlformats.org/drawingml/2006/main">
               <a:ext uri="{FF2B5EF4-FFF2-40B4-BE49-F238E27FC236}">
-                <a16:creationId xmlns:a16="http://schemas.microsoft.com/office/drawing/2014/main" id="{4FAA1849-3C0C-4F0B-B146-5D80E5A1DB33}"/>
+                <a16:creationId xmlns:a16="http://schemas.microsoft.com/office/drawing/2014/main" id="{C7DC4529-56E7-40DA-A327-1B3899C2473C}"/>
               </a:ext>
             </a:extLst>
           </p:cNvPr>
@@ -2663,7 +2663,7 @@
           <p:cNvPr id="8" name="">
             <a:extLst xmlns:a="http://schemas.openxmlformats.org/drawingml/2006/main">
               <a:ext uri="{FF2B5EF4-FFF2-40B4-BE49-F238E27FC236}">
-                <a16:creationId xmlns:a16="http://schemas.microsoft.com/office/drawing/2014/main" id="{106DCAB4-8597-468E-871F-364AB3B45793}"/>
+                <a16:creationId xmlns:a16="http://schemas.microsoft.com/office/drawing/2014/main" id="{57A6F0CA-89AA-4AB6-A46A-815D60386E73}"/>
               </a:ext>
             </a:extLst>
           </p:cNvPr>
@@ -2713,7 +2713,7 @@
           <p:cNvPr id="9" name="">
             <a:extLst xmlns:a="http://schemas.openxmlformats.org/drawingml/2006/main">
               <a:ext uri="{FF2B5EF4-FFF2-40B4-BE49-F238E27FC236}">
-                <a16:creationId xmlns:a16="http://schemas.microsoft.com/office/drawing/2014/main" id="{CA8F4EF6-C2BE-4C74-AF1C-E1B774A2761E}"/>
+                <a16:creationId xmlns:a16="http://schemas.microsoft.com/office/drawing/2014/main" id="{1B0E467F-1A6E-4FA0-9B87-1A6855E92A51}"/>
               </a:ext>
             </a:extLst>
           </p:cNvPr>
@@ -2748,7 +2748,7 @@
           <p:cNvPr id="10" name="">
             <a:extLst xmlns:a="http://schemas.openxmlformats.org/drawingml/2006/main">
               <a:ext uri="{FF2B5EF4-FFF2-40B4-BE49-F238E27FC236}">
-                <a16:creationId xmlns:a16="http://schemas.microsoft.com/office/drawing/2014/main" id="{BBD04AC7-817B-4D00-BEA0-CD7ACFBCBDEF}"/>
+                <a16:creationId xmlns:a16="http://schemas.microsoft.com/office/drawing/2014/main" id="{711003FB-5405-4259-863C-35594D51CE6F}"/>
               </a:ext>
             </a:extLst>
           </p:cNvPr>
@@ -2798,7 +2798,7 @@
           <p:cNvPr id="11" name="">
             <a:extLst xmlns:a="http://schemas.openxmlformats.org/drawingml/2006/main">
               <a:ext uri="{FF2B5EF4-FFF2-40B4-BE49-F238E27FC236}">
-                <a16:creationId xmlns:a16="http://schemas.microsoft.com/office/drawing/2014/main" id="{353AA243-9B0D-4187-86E8-794E9E4EA45B}"/>
+                <a16:creationId xmlns:a16="http://schemas.microsoft.com/office/drawing/2014/main" id="{5A21AD62-3687-43DF-8D29-FBB1899A8C9E}"/>
               </a:ext>
             </a:extLst>
           </p:cNvPr>
@@ -2848,7 +2848,7 @@
           <p:cNvPr id="12" name="">
             <a:extLst xmlns:a="http://schemas.openxmlformats.org/drawingml/2006/main">
               <a:ext uri="{FF2B5EF4-FFF2-40B4-BE49-F238E27FC236}">
-                <a16:creationId xmlns:a16="http://schemas.microsoft.com/office/drawing/2014/main" id="{283AFB6F-F9D9-4BD3-8EF9-3E1E1041DFA8}"/>
+                <a16:creationId xmlns:a16="http://schemas.microsoft.com/office/drawing/2014/main" id="{1078F6A9-8F20-4748-8A4D-8CF8B5549E55}"/>
               </a:ext>
             </a:extLst>
           </p:cNvPr>
@@ -2898,7 +2898,7 @@
           <p:cNvPr id="13" name="">
             <a:extLst xmlns:a="http://schemas.openxmlformats.org/drawingml/2006/main">
               <a:ext uri="{FF2B5EF4-FFF2-40B4-BE49-F238E27FC236}">
-                <a16:creationId xmlns:a16="http://schemas.microsoft.com/office/drawing/2014/main" id="{76CF1587-BDC0-4417-957C-71D344766EBD}"/>
+                <a16:creationId xmlns:a16="http://schemas.microsoft.com/office/drawing/2014/main" id="{2652F47C-D5ED-4C5C-B76C-D3B2F16D7472}"/>
               </a:ext>
             </a:extLst>
           </p:cNvPr>
@@ -2933,7 +2933,7 @@
           <p:cNvPr id="14" name="">
             <a:extLst xmlns:a="http://schemas.openxmlformats.org/drawingml/2006/main">
               <a:ext uri="{FF2B5EF4-FFF2-40B4-BE49-F238E27FC236}">
-                <a16:creationId xmlns:a16="http://schemas.microsoft.com/office/drawing/2014/main" id="{CEF04883-06FC-4085-B56D-C49DA00B4817}"/>
+                <a16:creationId xmlns:a16="http://schemas.microsoft.com/office/drawing/2014/main" id="{26057BA8-7BDA-46E8-ABDB-DD181F33CD32}"/>
               </a:ext>
             </a:extLst>
           </p:cNvPr>
@@ -2983,7 +2983,7 @@
           <p:cNvPr id="15" name="">
             <a:extLst xmlns:a="http://schemas.openxmlformats.org/drawingml/2006/main">
               <a:ext uri="{FF2B5EF4-FFF2-40B4-BE49-F238E27FC236}">
-                <a16:creationId xmlns:a16="http://schemas.microsoft.com/office/drawing/2014/main" id="{5D2CD964-1066-46A4-84A0-43F2B85C9DCE}"/>
+                <a16:creationId xmlns:a16="http://schemas.microsoft.com/office/drawing/2014/main" id="{938C0F0D-BEE9-4E5F-B56C-C42176CD2560}"/>
               </a:ext>
             </a:extLst>
           </p:cNvPr>
@@ -3033,7 +3033,7 @@
           <p:cNvPr id="16" name="">
             <a:extLst xmlns:a="http://schemas.openxmlformats.org/drawingml/2006/main">
               <a:ext uri="{FF2B5EF4-FFF2-40B4-BE49-F238E27FC236}">
-                <a16:creationId xmlns:a16="http://schemas.microsoft.com/office/drawing/2014/main" id="{26339FA4-00A6-48BD-BFDE-EEF15E518745}"/>
+                <a16:creationId xmlns:a16="http://schemas.microsoft.com/office/drawing/2014/main" id="{C7BB54F1-D0D1-4B1B-A23E-D5A63CB358DA}"/>
               </a:ext>
             </a:extLst>
           </p:cNvPr>
@@ -3083,7 +3083,7 @@
           <p:cNvPr id="17" name="">
             <a:extLst xmlns:a="http://schemas.openxmlformats.org/drawingml/2006/main">
               <a:ext uri="{FF2B5EF4-FFF2-40B4-BE49-F238E27FC236}">
-                <a16:creationId xmlns:a16="http://schemas.microsoft.com/office/drawing/2014/main" id="{740D6BBA-3730-4139-807E-E16A043402F0}"/>
+                <a16:creationId xmlns:a16="http://schemas.microsoft.com/office/drawing/2014/main" id="{3F3E8811-B4EA-483F-BE32-725733BCC6AD}"/>
               </a:ext>
             </a:extLst>
           </p:cNvPr>
@@ -3133,7 +3133,7 @@
           <p:cNvPr id="18" name="">
             <a:extLst xmlns:a="http://schemas.openxmlformats.org/drawingml/2006/main">
               <a:ext uri="{FF2B5EF4-FFF2-40B4-BE49-F238E27FC236}">
-                <a16:creationId xmlns:a16="http://schemas.microsoft.com/office/drawing/2014/main" id="{E3072A34-D914-4416-B4F3-F2B5A944D5B5}"/>
+                <a16:creationId xmlns:a16="http://schemas.microsoft.com/office/drawing/2014/main" id="{FA94B59D-46DA-4EA3-89CD-40A08C3796D0}"/>
               </a:ext>
             </a:extLst>
           </p:cNvPr>
@@ -3164,7 +3164,7 @@
           <p:cNvPr id="19" name="">
             <a:extLst xmlns:a="http://schemas.openxmlformats.org/drawingml/2006/main">
               <a:ext uri="{FF2B5EF4-FFF2-40B4-BE49-F238E27FC236}">
-                <a16:creationId xmlns:a16="http://schemas.microsoft.com/office/drawing/2014/main" id="{24E52EF0-FDAC-44EC-A95B-FB33507A10CF}"/>
+                <a16:creationId xmlns:a16="http://schemas.microsoft.com/office/drawing/2014/main" id="{7AC4FC63-07E4-48E3-95C9-DFA6229DA511}"/>
               </a:ext>
             </a:extLst>
           </p:cNvPr>
@@ -3214,7 +3214,7 @@
           <p:cNvPr id="20" name="">
             <a:extLst xmlns:a="http://schemas.openxmlformats.org/drawingml/2006/main">
               <a:ext uri="{FF2B5EF4-FFF2-40B4-BE49-F238E27FC236}">
-                <a16:creationId xmlns:a16="http://schemas.microsoft.com/office/drawing/2014/main" id="{F497402B-26CB-41EC-B656-9043BBE5CFAB}"/>
+                <a16:creationId xmlns:a16="http://schemas.microsoft.com/office/drawing/2014/main" id="{68A76A1B-773B-4E8B-8740-86AD378FEFD0}"/>
               </a:ext>
             </a:extLst>
           </p:cNvPr>
@@ -3262,7 +3262,7 @@
     </p:spTree>
     <p:extLst>
       <p:ext uri="{BB962C8B-B14F-4D97-AF65-F5344CB8AC3E}">
-        <p14:creationId xmlns:p14="http://schemas.microsoft.com/office/powerpoint/2010/main" val="467535348"/>
+        <p14:creationId xmlns:p14="http://schemas.microsoft.com/office/powerpoint/2010/main" val="599612057"/>
       </p:ext>
     </p:extLst>
   </p:cSld>
@@ -3293,7 +3293,7 @@
           <p:cNvPr id="17" name="">
             <a:extLst xmlns:a="http://schemas.openxmlformats.org/drawingml/2006/main">
               <a:ext uri="{FF2B5EF4-FFF2-40B4-BE49-F238E27FC236}">
-                <a16:creationId xmlns:a16="http://schemas.microsoft.com/office/drawing/2014/main" id="{2B6BF784-F4F3-44AF-8F35-2B956CCA0BF0}"/>
+                <a16:creationId xmlns:a16="http://schemas.microsoft.com/office/drawing/2014/main" id="{036294C3-5DC5-42E9-98B8-631F3B9C31CD}"/>
               </a:ext>
             </a:extLst>
           </p:cNvPr>
@@ -3343,7 +3343,7 @@
           <p:cNvPr id="2" name="">
             <a:extLst xmlns:a="http://schemas.openxmlformats.org/drawingml/2006/main">
               <a:ext uri="{FF2B5EF4-FFF2-40B4-BE49-F238E27FC236}">
-                <a16:creationId xmlns:a16="http://schemas.microsoft.com/office/drawing/2014/main" id="{E01C47B6-8143-440E-96BB-75ED853B09B6}"/>
+                <a16:creationId xmlns:a16="http://schemas.microsoft.com/office/drawing/2014/main" id="{3BB86517-9483-4E79-8E6F-E6D16604E5EF}"/>
               </a:ext>
             </a:extLst>
           </p:cNvPr>
@@ -3393,7 +3393,7 @@
           <p:cNvPr id="3" name="">
             <a:extLst xmlns:a="http://schemas.openxmlformats.org/drawingml/2006/main">
               <a:ext uri="{FF2B5EF4-FFF2-40B4-BE49-F238E27FC236}">
-                <a16:creationId xmlns:a16="http://schemas.microsoft.com/office/drawing/2014/main" id="{390874B1-C6E3-47BF-9C0D-D7617242ECDF}"/>
+                <a16:creationId xmlns:a16="http://schemas.microsoft.com/office/drawing/2014/main" id="{6E94E5C4-31AF-4E38-A511-B7F3421F39D1}"/>
               </a:ext>
             </a:extLst>
           </p:cNvPr>
@@ -3447,7 +3447,7 @@
           <p:nvPr/>
         </p:nvPicPr>
         <p:blipFill>
-          <a:blip xmlns:r="http://schemas.openxmlformats.org/officeDocument/2006/relationships" xmlns:a="http://schemas.openxmlformats.org/drawingml/2006/main" r:embed="R52506ddb650f4cfe"/>
+          <a:blip xmlns:r="http://schemas.openxmlformats.org/officeDocument/2006/relationships" xmlns:a="http://schemas.openxmlformats.org/drawingml/2006/main" r:embed="R09a679213f884785"/>
           <a:stretch xmlns:a="http://schemas.openxmlformats.org/drawingml/2006/main"/>
         </p:blipFill>
         <p:spPr>
@@ -3467,7 +3467,7 @@
           <p:cNvPr id="5" name="">
             <a:extLst xmlns:a="http://schemas.openxmlformats.org/drawingml/2006/main">
               <a:ext uri="{FF2B5EF4-FFF2-40B4-BE49-F238E27FC236}">
-                <a16:creationId xmlns:a16="http://schemas.microsoft.com/office/drawing/2014/main" id="{73C6875E-BFFA-4BFC-8637-299443BA6E21}"/>
+                <a16:creationId xmlns:a16="http://schemas.microsoft.com/office/drawing/2014/main" id="{53B94B95-D1AE-4E35-BAA1-2E3DD0BEE03E}"/>
               </a:ext>
             </a:extLst>
           </p:cNvPr>
@@ -3521,7 +3521,7 @@
           <p:nvPr/>
         </p:nvPicPr>
         <p:blipFill>
-          <a:blip xmlns:r="http://schemas.openxmlformats.org/officeDocument/2006/relationships" xmlns:a="http://schemas.openxmlformats.org/drawingml/2006/main" r:embed="R9124a51af47446ec"/>
+          <a:blip xmlns:r="http://schemas.openxmlformats.org/officeDocument/2006/relationships" xmlns:a="http://schemas.openxmlformats.org/drawingml/2006/main" r:embed="R6b479cc0ce4940ac"/>
           <a:stretch xmlns:a="http://schemas.openxmlformats.org/drawingml/2006/main"/>
         </p:blipFill>
         <p:spPr>
@@ -3541,7 +3541,7 @@
           <p:cNvPr id="7" name="">
             <a:extLst xmlns:a="http://schemas.openxmlformats.org/drawingml/2006/main">
               <a:ext uri="{FF2B5EF4-FFF2-40B4-BE49-F238E27FC236}">
-                <a16:creationId xmlns:a16="http://schemas.microsoft.com/office/drawing/2014/main" id="{C35687BC-1FEE-405C-A270-125F7C1B7E63}"/>
+                <a16:creationId xmlns:a16="http://schemas.microsoft.com/office/drawing/2014/main" id="{A1799C8C-491B-4BD6-9CE3-D648B9FCF612}"/>
               </a:ext>
             </a:extLst>
           </p:cNvPr>
@@ -3595,7 +3595,7 @@
           <p:nvPr/>
         </p:nvPicPr>
         <p:blipFill>
-          <a:blip xmlns:r="http://schemas.openxmlformats.org/officeDocument/2006/relationships" xmlns:a="http://schemas.openxmlformats.org/drawingml/2006/main" r:embed="R53ffa55868ce4d95"/>
+          <a:blip xmlns:r="http://schemas.openxmlformats.org/officeDocument/2006/relationships" xmlns:a="http://schemas.openxmlformats.org/drawingml/2006/main" r:embed="Re12396d2a8924062"/>
           <a:stretch xmlns:a="http://schemas.openxmlformats.org/drawingml/2006/main"/>
         </p:blipFill>
         <p:spPr>
@@ -3615,7 +3615,7 @@
           <p:cNvPr id="9" name="">
             <a:extLst xmlns:a="http://schemas.openxmlformats.org/drawingml/2006/main">
               <a:ext uri="{FF2B5EF4-FFF2-40B4-BE49-F238E27FC236}">
-                <a16:creationId xmlns:a16="http://schemas.microsoft.com/office/drawing/2014/main" id="{B4C37CE2-A5A2-4615-8366-E60DD1AE1E7B}"/>
+                <a16:creationId xmlns:a16="http://schemas.microsoft.com/office/drawing/2014/main" id="{37CADFBA-D060-4893-B381-6C0254B3320B}"/>
               </a:ext>
             </a:extLst>
           </p:cNvPr>
@@ -3669,7 +3669,7 @@
           <p:nvPr/>
         </p:nvPicPr>
         <p:blipFill>
-          <a:blip xmlns:r="http://schemas.openxmlformats.org/officeDocument/2006/relationships" xmlns:a="http://schemas.openxmlformats.org/drawingml/2006/main" r:embed="Rccd29db9be1a4bbf"/>
+          <a:blip xmlns:r="http://schemas.openxmlformats.org/officeDocument/2006/relationships" xmlns:a="http://schemas.openxmlformats.org/drawingml/2006/main" r:embed="Rf92fdcc1cd7a4dcf"/>
           <a:stretch xmlns:a="http://schemas.openxmlformats.org/drawingml/2006/main"/>
         </p:blipFill>
         <p:spPr>
@@ -3689,7 +3689,7 @@
           <p:cNvPr id="11" name="">
             <a:extLst xmlns:a="http://schemas.openxmlformats.org/drawingml/2006/main">
               <a:ext uri="{FF2B5EF4-FFF2-40B4-BE49-F238E27FC236}">
-                <a16:creationId xmlns:a16="http://schemas.microsoft.com/office/drawing/2014/main" id="{799C28D9-A5F5-4AFF-A5DB-FE3BBE198433}"/>
+                <a16:creationId xmlns:a16="http://schemas.microsoft.com/office/drawing/2014/main" id="{6CBBB1DB-788C-4E55-A0B8-BD9547E190DB}"/>
               </a:ext>
             </a:extLst>
           </p:cNvPr>
@@ -3739,7 +3739,7 @@
           <p:cNvPr id="12" name="">
             <a:extLst xmlns:a="http://schemas.openxmlformats.org/drawingml/2006/main">
               <a:ext uri="{FF2B5EF4-FFF2-40B4-BE49-F238E27FC236}">
-                <a16:creationId xmlns:a16="http://schemas.microsoft.com/office/drawing/2014/main" id="{78A12A94-EB22-4720-8A4B-795094395626}"/>
+                <a16:creationId xmlns:a16="http://schemas.microsoft.com/office/drawing/2014/main" id="{49D9C600-86FB-450E-B148-7716E2FD76D4}"/>
               </a:ext>
             </a:extLst>
           </p:cNvPr>
@@ -3789,7 +3789,7 @@
           <p:cNvPr id="13" name="">
             <a:extLst xmlns:a="http://schemas.openxmlformats.org/drawingml/2006/main">
               <a:ext uri="{FF2B5EF4-FFF2-40B4-BE49-F238E27FC236}">
-                <a16:creationId xmlns:a16="http://schemas.microsoft.com/office/drawing/2014/main" id="{32743B9D-B679-434B-AFA2-517B17D7DE3C}"/>
+                <a16:creationId xmlns:a16="http://schemas.microsoft.com/office/drawing/2014/main" id="{2C1FEFE4-D28E-400C-A3E9-6AD23FDC1FCA}"/>
               </a:ext>
             </a:extLst>
           </p:cNvPr>
@@ -3839,7 +3839,7 @@
           <p:cNvPr id="14" name="">
             <a:extLst xmlns:a="http://schemas.openxmlformats.org/drawingml/2006/main">
               <a:ext uri="{FF2B5EF4-FFF2-40B4-BE49-F238E27FC236}">
-                <a16:creationId xmlns:a16="http://schemas.microsoft.com/office/drawing/2014/main" id="{C5F14A1B-A3E4-42EC-845D-788BCA724A3C}"/>
+                <a16:creationId xmlns:a16="http://schemas.microsoft.com/office/drawing/2014/main" id="{103AB142-DCC2-4927-8842-116E8D5D073F}"/>
               </a:ext>
             </a:extLst>
           </p:cNvPr>
@@ -3870,7 +3870,7 @@
           <p:cNvPr id="15" name="">
             <a:extLst xmlns:a="http://schemas.openxmlformats.org/drawingml/2006/main">
               <a:ext uri="{FF2B5EF4-FFF2-40B4-BE49-F238E27FC236}">
-                <a16:creationId xmlns:a16="http://schemas.microsoft.com/office/drawing/2014/main" id="{742FA109-C5CD-46D5-8BBB-5CC37AF294CB}"/>
+                <a16:creationId xmlns:a16="http://schemas.microsoft.com/office/drawing/2014/main" id="{C58E99CE-AFE5-4286-AC08-3B7DBB4C60B8}"/>
               </a:ext>
             </a:extLst>
           </p:cNvPr>
@@ -3920,7 +3920,7 @@
           <p:cNvPr id="16" name="">
             <a:extLst xmlns:a="http://schemas.openxmlformats.org/drawingml/2006/main">
               <a:ext uri="{FF2B5EF4-FFF2-40B4-BE49-F238E27FC236}">
-                <a16:creationId xmlns:a16="http://schemas.microsoft.com/office/drawing/2014/main" id="{7AD32212-210C-4116-993A-9CC07D82E19D}"/>
+                <a16:creationId xmlns:a16="http://schemas.microsoft.com/office/drawing/2014/main" id="{50868C9D-98A6-4EDB-BB8C-B6DB3B910D36}"/>
               </a:ext>
             </a:extLst>
           </p:cNvPr>
@@ -3968,7 +3968,7 @@
     </p:spTree>
     <p:extLst>
       <p:ext uri="{BB962C8B-B14F-4D97-AF65-F5344CB8AC3E}">
-        <p14:creationId xmlns:p14="http://schemas.microsoft.com/office/powerpoint/2010/main" val="211678947"/>
+        <p14:creationId xmlns:p14="http://schemas.microsoft.com/office/powerpoint/2010/main" val="1541842879"/>
       </p:ext>
     </p:extLst>
   </p:cSld>
@@ -3999,7 +3999,7 @@
           <p:cNvPr id="20" name="">
             <a:extLst xmlns:a="http://schemas.openxmlformats.org/drawingml/2006/main">
               <a:ext uri="{FF2B5EF4-FFF2-40B4-BE49-F238E27FC236}">
-                <a16:creationId xmlns:a16="http://schemas.microsoft.com/office/drawing/2014/main" id="{456BFCD2-8F95-41A4-9EFE-3BB906C1A6B5}"/>
+                <a16:creationId xmlns:a16="http://schemas.microsoft.com/office/drawing/2014/main" id="{A64AAE92-BF31-4F46-9C81-67E82A6B18F4}"/>
               </a:ext>
             </a:extLst>
           </p:cNvPr>
@@ -4049,7 +4049,7 @@
           <p:cNvPr id="2" name="">
             <a:extLst xmlns:a="http://schemas.openxmlformats.org/drawingml/2006/main">
               <a:ext uri="{FF2B5EF4-FFF2-40B4-BE49-F238E27FC236}">
-                <a16:creationId xmlns:a16="http://schemas.microsoft.com/office/drawing/2014/main" id="{C2A14190-91A8-4B1C-925C-132360C3232B}"/>
+                <a16:creationId xmlns:a16="http://schemas.microsoft.com/office/drawing/2014/main" id="{A37709B4-7979-482E-BDCC-F41AF68F1BE1}"/>
               </a:ext>
             </a:extLst>
           </p:cNvPr>
@@ -4099,7 +4099,7 @@
           <p:cNvPr id="3" name="">
             <a:extLst xmlns:a="http://schemas.openxmlformats.org/drawingml/2006/main">
               <a:ext uri="{FF2B5EF4-FFF2-40B4-BE49-F238E27FC236}">
-                <a16:creationId xmlns:a16="http://schemas.microsoft.com/office/drawing/2014/main" id="{637BC65C-E3CF-402F-9B5D-78B212E1AC02}"/>
+                <a16:creationId xmlns:a16="http://schemas.microsoft.com/office/drawing/2014/main" id="{95B482C5-EC33-4B92-85F5-01C5CDA718F9}"/>
               </a:ext>
             </a:extLst>
           </p:cNvPr>
@@ -4153,7 +4153,7 @@
           <p:nvPr/>
         </p:nvPicPr>
         <p:blipFill>
-          <a:blip xmlns:r="http://schemas.openxmlformats.org/officeDocument/2006/relationships" xmlns:a="http://schemas.openxmlformats.org/drawingml/2006/main" r:embed="R0096d3a585a74a21"/>
+          <a:blip xmlns:r="http://schemas.openxmlformats.org/officeDocument/2006/relationships" xmlns:a="http://schemas.openxmlformats.org/drawingml/2006/main" r:embed="R98709a81078646eb"/>
           <a:stretch xmlns:a="http://schemas.openxmlformats.org/drawingml/2006/main"/>
         </p:blipFill>
         <p:spPr>
@@ -4173,7 +4173,7 @@
           <p:cNvPr id="5" name="">
             <a:extLst xmlns:a="http://schemas.openxmlformats.org/drawingml/2006/main">
               <a:ext uri="{FF2B5EF4-FFF2-40B4-BE49-F238E27FC236}">
-                <a16:creationId xmlns:a16="http://schemas.microsoft.com/office/drawing/2014/main" id="{82194CCA-C42E-4FCA-AFF9-C6063AE6E2A3}"/>
+                <a16:creationId xmlns:a16="http://schemas.microsoft.com/office/drawing/2014/main" id="{166040EA-B971-4987-B731-A4C93705AB28}"/>
               </a:ext>
             </a:extLst>
           </p:cNvPr>
@@ -4223,7 +4223,7 @@
           <p:cNvPr id="6" name="">
             <a:extLst xmlns:a="http://schemas.openxmlformats.org/drawingml/2006/main">
               <a:ext uri="{FF2B5EF4-FFF2-40B4-BE49-F238E27FC236}">
-                <a16:creationId xmlns:a16="http://schemas.microsoft.com/office/drawing/2014/main" id="{97D6D8BF-F79A-4D62-9ADA-3F0F90C90A82}"/>
+                <a16:creationId xmlns:a16="http://schemas.microsoft.com/office/drawing/2014/main" id="{E7B13ED0-ABBD-40F3-94D9-0185D2014D99}"/>
               </a:ext>
             </a:extLst>
           </p:cNvPr>
@@ -4273,7 +4273,7 @@
           <p:cNvPr id="7" name="">
             <a:extLst xmlns:a="http://schemas.openxmlformats.org/drawingml/2006/main">
               <a:ext uri="{FF2B5EF4-FFF2-40B4-BE49-F238E27FC236}">
-                <a16:creationId xmlns:a16="http://schemas.microsoft.com/office/drawing/2014/main" id="{AC8EB336-9547-4169-AA85-FA2A3CEB63FB}"/>
+                <a16:creationId xmlns:a16="http://schemas.microsoft.com/office/drawing/2014/main" id="{AFE3F118-2582-4ECF-8795-BD037D7FAF4B}"/>
               </a:ext>
             </a:extLst>
           </p:cNvPr>
@@ -4323,7 +4323,7 @@
           <p:cNvPr id="8" name="">
             <a:extLst xmlns:a="http://schemas.openxmlformats.org/drawingml/2006/main">
               <a:ext uri="{FF2B5EF4-FFF2-40B4-BE49-F238E27FC236}">
-                <a16:creationId xmlns:a16="http://schemas.microsoft.com/office/drawing/2014/main" id="{61E73584-0410-4094-8F22-DE013E720138}"/>
+                <a16:creationId xmlns:a16="http://schemas.microsoft.com/office/drawing/2014/main" id="{D444282E-0D85-42CC-9616-43D94CF7E30E}"/>
               </a:ext>
             </a:extLst>
           </p:cNvPr>
@@ -4354,7 +4354,7 @@
           <p:cNvPr id="9" name="">
             <a:extLst xmlns:a="http://schemas.openxmlformats.org/drawingml/2006/main">
               <a:ext uri="{FF2B5EF4-FFF2-40B4-BE49-F238E27FC236}">
-                <a16:creationId xmlns:a16="http://schemas.microsoft.com/office/drawing/2014/main" id="{9B469E8F-0C92-4A0E-885D-FACDE4911D8E}"/>
+                <a16:creationId xmlns:a16="http://schemas.microsoft.com/office/drawing/2014/main" id="{D15E41F7-26DF-4FB0-A632-B1EDC8036204}"/>
               </a:ext>
             </a:extLst>
           </p:cNvPr>
@@ -4404,7 +4404,7 @@
           <p:cNvPr id="10" name="">
             <a:extLst xmlns:a="http://schemas.openxmlformats.org/drawingml/2006/main">
               <a:ext uri="{FF2B5EF4-FFF2-40B4-BE49-F238E27FC236}">
-                <a16:creationId xmlns:a16="http://schemas.microsoft.com/office/drawing/2014/main" id="{A3AF13F8-EE5D-4AC6-BF70-9BA30E837079}"/>
+                <a16:creationId xmlns:a16="http://schemas.microsoft.com/office/drawing/2014/main" id="{06B75EDB-BCB6-47D4-A1CD-3556D2767A01}"/>
               </a:ext>
             </a:extLst>
           </p:cNvPr>
@@ -4454,7 +4454,7 @@
           <p:cNvPr id="11" name="">
             <a:extLst xmlns:a="http://schemas.openxmlformats.org/drawingml/2006/main">
               <a:ext uri="{FF2B5EF4-FFF2-40B4-BE49-F238E27FC236}">
-                <a16:creationId xmlns:a16="http://schemas.microsoft.com/office/drawing/2014/main" id="{89B4699F-E7BC-4DF9-AA88-56AD914C8347}"/>
+                <a16:creationId xmlns:a16="http://schemas.microsoft.com/office/drawing/2014/main" id="{6FE40F82-832F-42CE-B9E6-5DCD4C68793B}"/>
               </a:ext>
             </a:extLst>
           </p:cNvPr>
@@ -4504,7 +4504,7 @@
           <p:cNvPr id="12" name="">
             <a:extLst xmlns:a="http://schemas.openxmlformats.org/drawingml/2006/main">
               <a:ext uri="{FF2B5EF4-FFF2-40B4-BE49-F238E27FC236}">
-                <a16:creationId xmlns:a16="http://schemas.microsoft.com/office/drawing/2014/main" id="{05643E91-B2D3-4542-8D6F-73EAA7E97E99}"/>
+                <a16:creationId xmlns:a16="http://schemas.microsoft.com/office/drawing/2014/main" id="{08A836F8-ED23-441B-BF2E-E5EA642CF466}"/>
               </a:ext>
             </a:extLst>
           </p:cNvPr>
@@ -4535,7 +4535,7 @@
           <p:cNvPr id="13" name="">
             <a:extLst xmlns:a="http://schemas.openxmlformats.org/drawingml/2006/main">
               <a:ext uri="{FF2B5EF4-FFF2-40B4-BE49-F238E27FC236}">
-                <a16:creationId xmlns:a16="http://schemas.microsoft.com/office/drawing/2014/main" id="{14DB38ED-5299-4133-9E79-5A562940A5CE}"/>
+                <a16:creationId xmlns:a16="http://schemas.microsoft.com/office/drawing/2014/main" id="{C8D1FC13-E964-4CA7-9071-02137AA89257}"/>
               </a:ext>
             </a:extLst>
           </p:cNvPr>
@@ -4585,7 +4585,7 @@
           <p:cNvPr id="14" name="">
             <a:extLst xmlns:a="http://schemas.openxmlformats.org/drawingml/2006/main">
               <a:ext uri="{FF2B5EF4-FFF2-40B4-BE49-F238E27FC236}">
-                <a16:creationId xmlns:a16="http://schemas.microsoft.com/office/drawing/2014/main" id="{8FE9B769-849A-41D2-9FCE-2ED6A7B0E4EE}"/>
+                <a16:creationId xmlns:a16="http://schemas.microsoft.com/office/drawing/2014/main" id="{20A5086F-742F-4782-8627-D3270C3FAF9E}"/>
               </a:ext>
             </a:extLst>
           </p:cNvPr>
@@ -4635,7 +4635,7 @@
           <p:cNvPr id="15" name="">
             <a:extLst xmlns:a="http://schemas.openxmlformats.org/drawingml/2006/main">
               <a:ext uri="{FF2B5EF4-FFF2-40B4-BE49-F238E27FC236}">
-                <a16:creationId xmlns:a16="http://schemas.microsoft.com/office/drawing/2014/main" id="{7C3B5814-0E7C-4DC8-A7BA-F0D5C56B7EBC}"/>
+                <a16:creationId xmlns:a16="http://schemas.microsoft.com/office/drawing/2014/main" id="{981B5AA7-7250-4639-A9C2-0B19332A3D32}"/>
               </a:ext>
             </a:extLst>
           </p:cNvPr>
@@ -4685,7 +4685,7 @@
           <p:cNvPr id="16" name="">
             <a:extLst xmlns:a="http://schemas.openxmlformats.org/drawingml/2006/main">
               <a:ext uri="{FF2B5EF4-FFF2-40B4-BE49-F238E27FC236}">
-                <a16:creationId xmlns:a16="http://schemas.microsoft.com/office/drawing/2014/main" id="{944782D7-7E6F-45AD-8061-7345198904A3}"/>
+                <a16:creationId xmlns:a16="http://schemas.microsoft.com/office/drawing/2014/main" id="{B2646A02-BF08-4296-89B7-0A2550C7077E}"/>
               </a:ext>
             </a:extLst>
           </p:cNvPr>
@@ -4735,7 +4735,7 @@
           <p:cNvPr id="17" name="">
             <a:extLst xmlns:a="http://schemas.openxmlformats.org/drawingml/2006/main">
               <a:ext uri="{FF2B5EF4-FFF2-40B4-BE49-F238E27FC236}">
-                <a16:creationId xmlns:a16="http://schemas.microsoft.com/office/drawing/2014/main" id="{02FDA1DF-0F9A-4C20-A26B-EDF93A7DAFB0}"/>
+                <a16:creationId xmlns:a16="http://schemas.microsoft.com/office/drawing/2014/main" id="{7F8B5E03-19FB-4646-8F23-A350E235BA9A}"/>
               </a:ext>
             </a:extLst>
           </p:cNvPr>
@@ -4766,7 +4766,7 @@
           <p:cNvPr id="18" name="">
             <a:extLst xmlns:a="http://schemas.openxmlformats.org/drawingml/2006/main">
               <a:ext uri="{FF2B5EF4-FFF2-40B4-BE49-F238E27FC236}">
-                <a16:creationId xmlns:a16="http://schemas.microsoft.com/office/drawing/2014/main" id="{C9727462-5D46-4FA4-BD31-2111871B33D5}"/>
+                <a16:creationId xmlns:a16="http://schemas.microsoft.com/office/drawing/2014/main" id="{821D06BF-4791-4DBF-A2C3-17B480CEEA3D}"/>
               </a:ext>
             </a:extLst>
           </p:cNvPr>
@@ -4816,7 +4816,7 @@
           <p:cNvPr id="19" name="">
             <a:extLst xmlns:a="http://schemas.openxmlformats.org/drawingml/2006/main">
               <a:ext uri="{FF2B5EF4-FFF2-40B4-BE49-F238E27FC236}">
-                <a16:creationId xmlns:a16="http://schemas.microsoft.com/office/drawing/2014/main" id="{525E1768-22E2-4CB1-B879-97CC57D9AE76}"/>
+                <a16:creationId xmlns:a16="http://schemas.microsoft.com/office/drawing/2014/main" id="{83EF4235-9BF3-46A7-814C-37D33A4E209B}"/>
               </a:ext>
             </a:extLst>
           </p:cNvPr>
@@ -4864,7 +4864,7 @@
     </p:spTree>
     <p:extLst>
       <p:ext uri="{BB962C8B-B14F-4D97-AF65-F5344CB8AC3E}">
-        <p14:creationId xmlns:p14="http://schemas.microsoft.com/office/powerpoint/2010/main" val="726419319"/>
+        <p14:creationId xmlns:p14="http://schemas.microsoft.com/office/powerpoint/2010/main" val="1475302238"/>
       </p:ext>
     </p:extLst>
   </p:cSld>
@@ -4895,7 +4895,7 @@
           <p:cNvPr id="18" name="">
             <a:extLst xmlns:a="http://schemas.openxmlformats.org/drawingml/2006/main">
               <a:ext uri="{FF2B5EF4-FFF2-40B4-BE49-F238E27FC236}">
-                <a16:creationId xmlns:a16="http://schemas.microsoft.com/office/drawing/2014/main" id="{F33A03A4-1CA4-41EA-BC7E-41105293C149}"/>
+                <a16:creationId xmlns:a16="http://schemas.microsoft.com/office/drawing/2014/main" id="{3B4B73C9-31D8-4842-895B-4A569B04F5D9}"/>
               </a:ext>
             </a:extLst>
           </p:cNvPr>
@@ -4945,7 +4945,7 @@
           <p:cNvPr id="2" name="">
             <a:extLst xmlns:a="http://schemas.openxmlformats.org/drawingml/2006/main">
               <a:ext uri="{FF2B5EF4-FFF2-40B4-BE49-F238E27FC236}">
-                <a16:creationId xmlns:a16="http://schemas.microsoft.com/office/drawing/2014/main" id="{043E18FE-E854-4B1A-8B1E-1CBBA4A55957}"/>
+                <a16:creationId xmlns:a16="http://schemas.microsoft.com/office/drawing/2014/main" id="{AC0505B3-D642-4CFF-9AAD-603BBD0FF4B1}"/>
               </a:ext>
             </a:extLst>
           </p:cNvPr>
@@ -4995,7 +4995,7 @@
           <p:cNvPr id="3" name="">
             <a:extLst xmlns:a="http://schemas.openxmlformats.org/drawingml/2006/main">
               <a:ext uri="{FF2B5EF4-FFF2-40B4-BE49-F238E27FC236}">
-                <a16:creationId xmlns:a16="http://schemas.microsoft.com/office/drawing/2014/main" id="{2567A1BE-EB87-4D20-A4A2-E686A43F3806}"/>
+                <a16:creationId xmlns:a16="http://schemas.microsoft.com/office/drawing/2014/main" id="{45C3EDE4-0F16-4D93-B8BA-B909D916C0CD}"/>
               </a:ext>
             </a:extLst>
           </p:cNvPr>
@@ -5049,7 +5049,7 @@
           <p:nvPr/>
         </p:nvPicPr>
         <p:blipFill>
-          <a:blip xmlns:r="http://schemas.openxmlformats.org/officeDocument/2006/relationships" xmlns:a="http://schemas.openxmlformats.org/drawingml/2006/main" r:embed="R6a5e0b704a4d4f3c"/>
+          <a:blip xmlns:r="http://schemas.openxmlformats.org/officeDocument/2006/relationships" xmlns:a="http://schemas.openxmlformats.org/drawingml/2006/main" r:embed="Rd23aa83ae3b34ca9"/>
           <a:srcRect xmlns:a="http://schemas.openxmlformats.org/drawingml/2006/main" l="352" t="0" r="352" b="0"/>
           <a:stretch xmlns:a="http://schemas.openxmlformats.org/drawingml/2006/main">
             <a:fillRect l="0" t="0" r="0" b="0"/>
@@ -5072,7 +5072,7 @@
           <p:cNvPr id="5" name="">
             <a:extLst xmlns:a="http://schemas.openxmlformats.org/drawingml/2006/main">
               <a:ext uri="{FF2B5EF4-FFF2-40B4-BE49-F238E27FC236}">
-                <a16:creationId xmlns:a16="http://schemas.microsoft.com/office/drawing/2014/main" id="{68213C99-EC46-4611-AE3B-F8030672AC9F}"/>
+                <a16:creationId xmlns:a16="http://schemas.microsoft.com/office/drawing/2014/main" id="{3901C49A-BAE3-460E-B166-30BD42CB1A9B}"/>
               </a:ext>
             </a:extLst>
           </p:cNvPr>
@@ -5122,7 +5122,7 @@
           <p:cNvPr id="6" name="">
             <a:extLst xmlns:a="http://schemas.openxmlformats.org/drawingml/2006/main">
               <a:ext uri="{FF2B5EF4-FFF2-40B4-BE49-F238E27FC236}">
-                <a16:creationId xmlns:a16="http://schemas.microsoft.com/office/drawing/2014/main" id="{DB031175-6963-490F-99BF-812270E44E33}"/>
+                <a16:creationId xmlns:a16="http://schemas.microsoft.com/office/drawing/2014/main" id="{46CE46A8-07E4-4D55-81E7-FBC2CED90C3C}"/>
               </a:ext>
             </a:extLst>
           </p:cNvPr>
@@ -5153,7 +5153,7 @@
           <p:cNvPr id="7" name="">
             <a:extLst xmlns:a="http://schemas.openxmlformats.org/drawingml/2006/main">
               <a:ext uri="{FF2B5EF4-FFF2-40B4-BE49-F238E27FC236}">
-                <a16:creationId xmlns:a16="http://schemas.microsoft.com/office/drawing/2014/main" id="{8C3C5336-DC0D-4D89-8E26-ECBC5847DCB9}"/>
+                <a16:creationId xmlns:a16="http://schemas.microsoft.com/office/drawing/2014/main" id="{04CC6A59-C5C3-4822-B000-A3F50A4F92D2}"/>
               </a:ext>
             </a:extLst>
           </p:cNvPr>
@@ -5203,7 +5203,7 @@
           <p:cNvPr id="8" name="">
             <a:extLst xmlns:a="http://schemas.openxmlformats.org/drawingml/2006/main">
               <a:ext uri="{FF2B5EF4-FFF2-40B4-BE49-F238E27FC236}">
-                <a16:creationId xmlns:a16="http://schemas.microsoft.com/office/drawing/2014/main" id="{C1CDB1B9-3CB9-4A64-8EFE-974D6A5B31AB}"/>
+                <a16:creationId xmlns:a16="http://schemas.microsoft.com/office/drawing/2014/main" id="{FDDEC25A-CB4D-434C-BDEA-D1565C76004D}"/>
               </a:ext>
             </a:extLst>
           </p:cNvPr>
@@ -5234,7 +5234,7 @@
           <p:cNvPr id="9" name="">
             <a:extLst xmlns:a="http://schemas.openxmlformats.org/drawingml/2006/main">
               <a:ext uri="{FF2B5EF4-FFF2-40B4-BE49-F238E27FC236}">
-                <a16:creationId xmlns:a16="http://schemas.microsoft.com/office/drawing/2014/main" id="{558922D0-9B27-41C0-88D3-A7FFEAE18ACD}"/>
+                <a16:creationId xmlns:a16="http://schemas.microsoft.com/office/drawing/2014/main" id="{4C02B7A8-9359-40F3-AD0B-9C906003E9BA}"/>
               </a:ext>
             </a:extLst>
           </p:cNvPr>
@@ -5284,7 +5284,7 @@
           <p:cNvPr id="10" name="">
             <a:extLst xmlns:a="http://schemas.openxmlformats.org/drawingml/2006/main">
               <a:ext uri="{FF2B5EF4-FFF2-40B4-BE49-F238E27FC236}">
-                <a16:creationId xmlns:a16="http://schemas.microsoft.com/office/drawing/2014/main" id="{C7235B89-BF1D-46E0-A36C-135EAA3B2F84}"/>
+                <a16:creationId xmlns:a16="http://schemas.microsoft.com/office/drawing/2014/main" id="{F0C85722-DE42-4EEE-96E9-821D1811D5B2}"/>
               </a:ext>
             </a:extLst>
           </p:cNvPr>
@@ -5315,7 +5315,7 @@
           <p:cNvPr id="11" name="">
             <a:extLst xmlns:a="http://schemas.openxmlformats.org/drawingml/2006/main">
               <a:ext uri="{FF2B5EF4-FFF2-40B4-BE49-F238E27FC236}">
-                <a16:creationId xmlns:a16="http://schemas.microsoft.com/office/drawing/2014/main" id="{B2D43AF4-41FF-409B-BA86-D9E6D5222876}"/>
+                <a16:creationId xmlns:a16="http://schemas.microsoft.com/office/drawing/2014/main" id="{11AE73C3-8FBC-407E-9039-BE9B5BCDCE06}"/>
               </a:ext>
             </a:extLst>
           </p:cNvPr>
@@ -5365,7 +5365,7 @@
           <p:cNvPr id="12" name="">
             <a:extLst xmlns:a="http://schemas.openxmlformats.org/drawingml/2006/main">
               <a:ext uri="{FF2B5EF4-FFF2-40B4-BE49-F238E27FC236}">
-                <a16:creationId xmlns:a16="http://schemas.microsoft.com/office/drawing/2014/main" id="{E2259844-5B30-4CEC-9384-786C633EA110}"/>
+                <a16:creationId xmlns:a16="http://schemas.microsoft.com/office/drawing/2014/main" id="{F022FC1B-04C8-4B9D-8AC6-31973091D82A}"/>
               </a:ext>
             </a:extLst>
           </p:cNvPr>
@@ -5396,7 +5396,7 @@
           <p:cNvPr id="13" name="">
             <a:extLst xmlns:a="http://schemas.openxmlformats.org/drawingml/2006/main">
               <a:ext uri="{FF2B5EF4-FFF2-40B4-BE49-F238E27FC236}">
-                <a16:creationId xmlns:a16="http://schemas.microsoft.com/office/drawing/2014/main" id="{9426CB99-C283-46B8-82AE-FA175EEEFF7A}"/>
+                <a16:creationId xmlns:a16="http://schemas.microsoft.com/office/drawing/2014/main" id="{F604EABC-DB54-4E9A-89BC-0D8E7381B335}"/>
               </a:ext>
             </a:extLst>
           </p:cNvPr>
@@ -5446,7 +5446,7 @@
           <p:cNvPr id="14" name="">
             <a:extLst xmlns:a="http://schemas.openxmlformats.org/drawingml/2006/main">
               <a:ext uri="{FF2B5EF4-FFF2-40B4-BE49-F238E27FC236}">
-                <a16:creationId xmlns:a16="http://schemas.microsoft.com/office/drawing/2014/main" id="{4E40DA2A-F98A-4035-9407-73CE2CF1DCEF}"/>
+                <a16:creationId xmlns:a16="http://schemas.microsoft.com/office/drawing/2014/main" id="{22BB80F8-A77D-4C44-A59F-4CBE90C7834F}"/>
               </a:ext>
             </a:extLst>
           </p:cNvPr>
@@ -5496,7 +5496,7 @@
           <p:cNvPr id="15" name="">
             <a:extLst xmlns:a="http://schemas.openxmlformats.org/drawingml/2006/main">
               <a:ext uri="{FF2B5EF4-FFF2-40B4-BE49-F238E27FC236}">
-                <a16:creationId xmlns:a16="http://schemas.microsoft.com/office/drawing/2014/main" id="{ECE435D3-601A-4E91-8BB9-BA9D9612A018}"/>
+                <a16:creationId xmlns:a16="http://schemas.microsoft.com/office/drawing/2014/main" id="{76AF6751-DD72-4D39-9E38-3E810B0AB0E9}"/>
               </a:ext>
             </a:extLst>
           </p:cNvPr>
@@ -5527,7 +5527,7 @@
           <p:cNvPr id="16" name="">
             <a:extLst xmlns:a="http://schemas.openxmlformats.org/drawingml/2006/main">
               <a:ext uri="{FF2B5EF4-FFF2-40B4-BE49-F238E27FC236}">
-                <a16:creationId xmlns:a16="http://schemas.microsoft.com/office/drawing/2014/main" id="{4CB56FBA-67C9-4151-8B69-6A650C45ED1A}"/>
+                <a16:creationId xmlns:a16="http://schemas.microsoft.com/office/drawing/2014/main" id="{0903782B-3354-4E6A-8525-A4019EC58C87}"/>
               </a:ext>
             </a:extLst>
           </p:cNvPr>
@@ -5577,7 +5577,7 @@
           <p:cNvPr id="17" name="">
             <a:extLst xmlns:a="http://schemas.openxmlformats.org/drawingml/2006/main">
               <a:ext uri="{FF2B5EF4-FFF2-40B4-BE49-F238E27FC236}">
-                <a16:creationId xmlns:a16="http://schemas.microsoft.com/office/drawing/2014/main" id="{ED19DE14-1B21-404F-A5EA-F2CE300DC289}"/>
+                <a16:creationId xmlns:a16="http://schemas.microsoft.com/office/drawing/2014/main" id="{6B2F75C3-C849-45F4-A999-7F62832174D5}"/>
               </a:ext>
             </a:extLst>
           </p:cNvPr>
@@ -5625,7 +5625,7 @@
     </p:spTree>
     <p:extLst>
       <p:ext uri="{BB962C8B-B14F-4D97-AF65-F5344CB8AC3E}">
-        <p14:creationId xmlns:p14="http://schemas.microsoft.com/office/powerpoint/2010/main" val="41284427"/>
+        <p14:creationId xmlns:p14="http://schemas.microsoft.com/office/powerpoint/2010/main" val="2004531445"/>
       </p:ext>
     </p:extLst>
   </p:cSld>
@@ -5656,7 +5656,7 @@
           <p:cNvPr id="22" name="">
             <a:extLst xmlns:a="http://schemas.openxmlformats.org/drawingml/2006/main">
               <a:ext uri="{FF2B5EF4-FFF2-40B4-BE49-F238E27FC236}">
-                <a16:creationId xmlns:a16="http://schemas.microsoft.com/office/drawing/2014/main" id="{9B1CEFB8-DB81-4CBD-8CC6-AD82A90A24B5}"/>
+                <a16:creationId xmlns:a16="http://schemas.microsoft.com/office/drawing/2014/main" id="{8F0066EA-5D90-4610-BD69-73C2C0A6444F}"/>
               </a:ext>
             </a:extLst>
           </p:cNvPr>
@@ -5706,7 +5706,7 @@
           <p:cNvPr id="2" name="">
             <a:extLst xmlns:a="http://schemas.openxmlformats.org/drawingml/2006/main">
               <a:ext uri="{FF2B5EF4-FFF2-40B4-BE49-F238E27FC236}">
-                <a16:creationId xmlns:a16="http://schemas.microsoft.com/office/drawing/2014/main" id="{DCF14089-B400-4428-BDB2-D22EC2A45269}"/>
+                <a16:creationId xmlns:a16="http://schemas.microsoft.com/office/drawing/2014/main" id="{AB66AA92-1ED8-4806-AEA1-D063887EA2D2}"/>
               </a:ext>
             </a:extLst>
           </p:cNvPr>
@@ -5756,7 +5756,7 @@
           <p:cNvPr id="3" name="">
             <a:extLst xmlns:a="http://schemas.openxmlformats.org/drawingml/2006/main">
               <a:ext uri="{FF2B5EF4-FFF2-40B4-BE49-F238E27FC236}">
-                <a16:creationId xmlns:a16="http://schemas.microsoft.com/office/drawing/2014/main" id="{C8091F42-B72E-4768-B9C2-D2D7919485F0}"/>
+                <a16:creationId xmlns:a16="http://schemas.microsoft.com/office/drawing/2014/main" id="{7F8BF253-5ADA-476C-8385-551BA0D32458}"/>
               </a:ext>
             </a:extLst>
           </p:cNvPr>
@@ -5823,7 +5823,7 @@
           <p:cNvPr id="4" name="">
             <a:extLst xmlns:a="http://schemas.openxmlformats.org/drawingml/2006/main">
               <a:ext uri="{FF2B5EF4-FFF2-40B4-BE49-F238E27FC236}">
-                <a16:creationId xmlns:a16="http://schemas.microsoft.com/office/drawing/2014/main" id="{0FCB0AB6-20CB-4FE5-A8A8-F3FCD5102A09}"/>
+                <a16:creationId xmlns:a16="http://schemas.microsoft.com/office/drawing/2014/main" id="{48C6B126-F7C4-495D-9917-EDE6EE90C559}"/>
               </a:ext>
             </a:extLst>
           </p:cNvPr>
@@ -5858,7 +5858,7 @@
           <p:cNvPr id="5" name="">
             <a:extLst xmlns:a="http://schemas.openxmlformats.org/drawingml/2006/main">
               <a:ext uri="{FF2B5EF4-FFF2-40B4-BE49-F238E27FC236}">
-                <a16:creationId xmlns:a16="http://schemas.microsoft.com/office/drawing/2014/main" id="{1EB8B22A-4CB1-490F-B544-9424D52C3363}"/>
+                <a16:creationId xmlns:a16="http://schemas.microsoft.com/office/drawing/2014/main" id="{54FB8CFA-7F13-4AD8-9730-8B86828D651A}"/>
               </a:ext>
             </a:extLst>
           </p:cNvPr>
@@ -5908,7 +5908,7 @@
           <p:cNvPr id="6" name="">
             <a:extLst xmlns:a="http://schemas.openxmlformats.org/drawingml/2006/main">
               <a:ext uri="{FF2B5EF4-FFF2-40B4-BE49-F238E27FC236}">
-                <a16:creationId xmlns:a16="http://schemas.microsoft.com/office/drawing/2014/main" id="{F8287764-1E5E-4F08-BC4E-06480812D876}"/>
+                <a16:creationId xmlns:a16="http://schemas.microsoft.com/office/drawing/2014/main" id="{14BA3A15-3DE3-4F3F-AD5B-091F96F698B4}"/>
               </a:ext>
             </a:extLst>
           </p:cNvPr>
@@ -5958,7 +5958,7 @@
           <p:cNvPr id="7" name="">
             <a:extLst xmlns:a="http://schemas.openxmlformats.org/drawingml/2006/main">
               <a:ext uri="{FF2B5EF4-FFF2-40B4-BE49-F238E27FC236}">
-                <a16:creationId xmlns:a16="http://schemas.microsoft.com/office/drawing/2014/main" id="{165E691C-24A8-4F6A-B777-4982CB212336}"/>
+                <a16:creationId xmlns:a16="http://schemas.microsoft.com/office/drawing/2014/main" id="{FFE82EF9-5A4F-4E76-BEAE-6CAF1DD01756}"/>
               </a:ext>
             </a:extLst>
           </p:cNvPr>
@@ -6008,7 +6008,7 @@
           <p:cNvPr id="8" name="">
             <a:extLst xmlns:a="http://schemas.openxmlformats.org/drawingml/2006/main">
               <a:ext uri="{FF2B5EF4-FFF2-40B4-BE49-F238E27FC236}">
-                <a16:creationId xmlns:a16="http://schemas.microsoft.com/office/drawing/2014/main" id="{77EB23CE-4A71-4FC4-856D-52AC7B5CEDAF}"/>
+                <a16:creationId xmlns:a16="http://schemas.microsoft.com/office/drawing/2014/main" id="{38000A0C-C932-4112-B579-B6CE2A136A8B}"/>
               </a:ext>
             </a:extLst>
           </p:cNvPr>
@@ -6043,7 +6043,7 @@
           <p:cNvPr id="9" name="">
             <a:extLst xmlns:a="http://schemas.openxmlformats.org/drawingml/2006/main">
               <a:ext uri="{FF2B5EF4-FFF2-40B4-BE49-F238E27FC236}">
-                <a16:creationId xmlns:a16="http://schemas.microsoft.com/office/drawing/2014/main" id="{16F1577D-75CE-4472-8F4F-F0A6313AE458}"/>
+                <a16:creationId xmlns:a16="http://schemas.microsoft.com/office/drawing/2014/main" id="{4BF38443-5EAA-40A4-A012-CEAE8C631ACC}"/>
               </a:ext>
             </a:extLst>
           </p:cNvPr>
@@ -6093,7 +6093,7 @@
           <p:cNvPr id="10" name="">
             <a:extLst xmlns:a="http://schemas.openxmlformats.org/drawingml/2006/main">
               <a:ext uri="{FF2B5EF4-FFF2-40B4-BE49-F238E27FC236}">
-                <a16:creationId xmlns:a16="http://schemas.microsoft.com/office/drawing/2014/main" id="{31C8A33D-9635-450C-9E21-5B0A5CBA53ED}"/>
+                <a16:creationId xmlns:a16="http://schemas.microsoft.com/office/drawing/2014/main" id="{91EEF858-182B-4233-8506-22D6699C1F58}"/>
               </a:ext>
             </a:extLst>
           </p:cNvPr>
@@ -6143,7 +6143,7 @@
           <p:cNvPr id="11" name="">
             <a:extLst xmlns:a="http://schemas.openxmlformats.org/drawingml/2006/main">
               <a:ext uri="{FF2B5EF4-FFF2-40B4-BE49-F238E27FC236}">
-                <a16:creationId xmlns:a16="http://schemas.microsoft.com/office/drawing/2014/main" id="{F448B24A-873D-4D20-A8FB-965FE1605C61}"/>
+                <a16:creationId xmlns:a16="http://schemas.microsoft.com/office/drawing/2014/main" id="{3E9E79D8-B175-4884-9760-9F72E96F05E3}"/>
               </a:ext>
             </a:extLst>
           </p:cNvPr>
@@ -6193,7 +6193,7 @@
           <p:cNvPr id="12" name="">
             <a:extLst xmlns:a="http://schemas.openxmlformats.org/drawingml/2006/main">
               <a:ext uri="{FF2B5EF4-FFF2-40B4-BE49-F238E27FC236}">
-                <a16:creationId xmlns:a16="http://schemas.microsoft.com/office/drawing/2014/main" id="{649A9738-F436-492B-B4B3-82F3076E8EF2}"/>
+                <a16:creationId xmlns:a16="http://schemas.microsoft.com/office/drawing/2014/main" id="{AC1D6EAA-6791-42F0-AB23-77042A9650EC}"/>
               </a:ext>
             </a:extLst>
           </p:cNvPr>
@@ -6228,7 +6228,7 @@
           <p:cNvPr id="13" name="">
             <a:extLst xmlns:a="http://schemas.openxmlformats.org/drawingml/2006/main">
               <a:ext uri="{FF2B5EF4-FFF2-40B4-BE49-F238E27FC236}">
-                <a16:creationId xmlns:a16="http://schemas.microsoft.com/office/drawing/2014/main" id="{5B3D2F06-6DDD-43C7-B88F-CF1C97B1A0AD}"/>
+                <a16:creationId xmlns:a16="http://schemas.microsoft.com/office/drawing/2014/main" id="{7BF7E115-A574-4544-87E7-DD18C77726DB}"/>
               </a:ext>
             </a:extLst>
           </p:cNvPr>
@@ -6278,7 +6278,7 @@
           <p:cNvPr id="14" name="">
             <a:extLst xmlns:a="http://schemas.openxmlformats.org/drawingml/2006/main">
               <a:ext uri="{FF2B5EF4-FFF2-40B4-BE49-F238E27FC236}">
-                <a16:creationId xmlns:a16="http://schemas.microsoft.com/office/drawing/2014/main" id="{7D6BECF1-AA9B-44BF-B170-76CFCDA1A201}"/>
+                <a16:creationId xmlns:a16="http://schemas.microsoft.com/office/drawing/2014/main" id="{53821BE8-B3B5-490D-A07E-02BA0820ED20}"/>
               </a:ext>
             </a:extLst>
           </p:cNvPr>
@@ -6328,7 +6328,7 @@
           <p:cNvPr id="15" name="">
             <a:extLst xmlns:a="http://schemas.openxmlformats.org/drawingml/2006/main">
               <a:ext uri="{FF2B5EF4-FFF2-40B4-BE49-F238E27FC236}">
-                <a16:creationId xmlns:a16="http://schemas.microsoft.com/office/drawing/2014/main" id="{D069661C-B13C-4410-B906-64D76C8BBFBA}"/>
+                <a16:creationId xmlns:a16="http://schemas.microsoft.com/office/drawing/2014/main" id="{ED492645-AF39-47AE-AF61-216B3CC27A39}"/>
               </a:ext>
             </a:extLst>
           </p:cNvPr>
@@ -6378,7 +6378,7 @@
           <p:cNvPr id="16" name="">
             <a:extLst xmlns:a="http://schemas.openxmlformats.org/drawingml/2006/main">
               <a:ext uri="{FF2B5EF4-FFF2-40B4-BE49-F238E27FC236}">
-                <a16:creationId xmlns:a16="http://schemas.microsoft.com/office/drawing/2014/main" id="{E2767A54-41D7-4F45-AFA1-CAB011F8FC76}"/>
+                <a16:creationId xmlns:a16="http://schemas.microsoft.com/office/drawing/2014/main" id="{38479706-C5C4-4386-BBF5-1A0D4DEE62F0}"/>
               </a:ext>
             </a:extLst>
           </p:cNvPr>
@@ -6428,7 +6428,7 @@
           <p:cNvPr id="17" name="">
             <a:extLst xmlns:a="http://schemas.openxmlformats.org/drawingml/2006/main">
               <a:ext uri="{FF2B5EF4-FFF2-40B4-BE49-F238E27FC236}">
-                <a16:creationId xmlns:a16="http://schemas.microsoft.com/office/drawing/2014/main" id="{09A9DDA8-4A26-44AC-93FB-F6F1900E4D8A}"/>
+                <a16:creationId xmlns:a16="http://schemas.microsoft.com/office/drawing/2014/main" id="{EB1A8935-66BE-4D0F-B81E-0CCABF3AA77A}"/>
               </a:ext>
             </a:extLst>
           </p:cNvPr>
@@ -6478,7 +6478,7 @@
           <p:cNvPr id="18" name="">
             <a:extLst xmlns:a="http://schemas.openxmlformats.org/drawingml/2006/main">
               <a:ext uri="{FF2B5EF4-FFF2-40B4-BE49-F238E27FC236}">
-                <a16:creationId xmlns:a16="http://schemas.microsoft.com/office/drawing/2014/main" id="{6049B081-8B36-43AE-920F-ED045ED20FFD}"/>
+                <a16:creationId xmlns:a16="http://schemas.microsoft.com/office/drawing/2014/main" id="{45AA5011-A8F4-41D4-825B-2173C948627A}"/>
               </a:ext>
             </a:extLst>
           </p:cNvPr>
@@ -6528,7 +6528,7 @@
           <p:cNvPr id="19" name="">
             <a:extLst xmlns:a="http://schemas.openxmlformats.org/drawingml/2006/main">
               <a:ext uri="{FF2B5EF4-FFF2-40B4-BE49-F238E27FC236}">
-                <a16:creationId xmlns:a16="http://schemas.microsoft.com/office/drawing/2014/main" id="{C351FFC4-CD39-4D52-96BC-DC88A9D9706C}"/>
+                <a16:creationId xmlns:a16="http://schemas.microsoft.com/office/drawing/2014/main" id="{CED3BC92-4886-41C7-95A5-7EBB7FF06DAC}"/>
               </a:ext>
             </a:extLst>
           </p:cNvPr>
@@ -6559,7 +6559,7 @@
           <p:cNvPr id="20" name="">
             <a:extLst xmlns:a="http://schemas.openxmlformats.org/drawingml/2006/main">
               <a:ext uri="{FF2B5EF4-FFF2-40B4-BE49-F238E27FC236}">
-                <a16:creationId xmlns:a16="http://schemas.microsoft.com/office/drawing/2014/main" id="{83F8AA15-06FB-4041-98E3-58F0A5C943C8}"/>
+                <a16:creationId xmlns:a16="http://schemas.microsoft.com/office/drawing/2014/main" id="{88F4169F-CEC4-4270-AEB5-4994665AF0F5}"/>
               </a:ext>
             </a:extLst>
           </p:cNvPr>
@@ -6609,7 +6609,7 @@
           <p:cNvPr id="21" name="">
             <a:extLst xmlns:a="http://schemas.openxmlformats.org/drawingml/2006/main">
               <a:ext uri="{FF2B5EF4-FFF2-40B4-BE49-F238E27FC236}">
-                <a16:creationId xmlns:a16="http://schemas.microsoft.com/office/drawing/2014/main" id="{B44F50D3-B6CA-49D3-99C7-96A482867355}"/>
+                <a16:creationId xmlns:a16="http://schemas.microsoft.com/office/drawing/2014/main" id="{4901AB67-F3A8-4BC1-8010-8952C59D4636}"/>
               </a:ext>
             </a:extLst>
           </p:cNvPr>
@@ -6657,7 +6657,7 @@
     </p:spTree>
     <p:extLst>
       <p:ext uri="{BB962C8B-B14F-4D97-AF65-F5344CB8AC3E}">
-        <p14:creationId xmlns:p14="http://schemas.microsoft.com/office/powerpoint/2010/main" val="1444789245"/>
+        <p14:creationId xmlns:p14="http://schemas.microsoft.com/office/powerpoint/2010/main" val="670526222"/>
       </p:ext>
     </p:extLst>
   </p:cSld>

</xml_diff>